<commit_message>
Added layers.Droput(0.3), to line 47
</commit_message>
<xml_diff>
--- a/IN501_Ridenour_Kresser_Meadows_Mpianin_Galarza_Unit9_Assignment.pptx
+++ b/IN501_Ridenour_Kresser_Meadows_Mpianin_Galarza_Unit9_Assignment.pptx
@@ -129,6 +129,50 @@
     </p:ext>
   </p:extLst>
 </p:presentation>
+</file>
+
+<file path=ppt/changesInfos/changesInfo1.xml><?xml version="1.0" encoding="utf-8"?>
+<pc:chgInfo xmlns:a="http://schemas.openxmlformats.org/drawingml/2006/main" xmlns:r="http://schemas.openxmlformats.org/officeDocument/2006/relationships" xmlns:ac="http://schemas.microsoft.com/office/drawing/2013/main/command" xmlns:pc="http://schemas.microsoft.com/office/powerpoint/2013/main/command">
+  <pc:docChgLst>
+    <pc:chgData name="Robert Kresser" userId="6239b4f0b95ea466" providerId="LiveId" clId="{61C80E82-EC96-4668-A2AA-2AE0A88FD26E}"/>
+    <pc:docChg chg="undo custSel modSld">
+      <pc:chgData name="Robert Kresser" userId="6239b4f0b95ea466" providerId="LiveId" clId="{61C80E82-EC96-4668-A2AA-2AE0A88FD26E}" dt="2026-03-05T23:16:25.303" v="88" actId="13926"/>
+      <pc:docMkLst>
+        <pc:docMk/>
+      </pc:docMkLst>
+      <pc:sldChg chg="modSp mod">
+        <pc:chgData name="Robert Kresser" userId="6239b4f0b95ea466" providerId="LiveId" clId="{61C80E82-EC96-4668-A2AA-2AE0A88FD26E}" dt="2026-03-05T23:15:35.339" v="61" actId="13926"/>
+        <pc:sldMkLst>
+          <pc:docMk/>
+          <pc:sldMk cId="0" sldId="259"/>
+        </pc:sldMkLst>
+        <pc:spChg chg="mod">
+          <ac:chgData name="Robert Kresser" userId="6239b4f0b95ea466" providerId="LiveId" clId="{61C80E82-EC96-4668-A2AA-2AE0A88FD26E}" dt="2026-03-05T23:15:35.339" v="61" actId="13926"/>
+          <ac:spMkLst>
+            <pc:docMk/>
+            <pc:sldMk cId="0" sldId="259"/>
+            <ac:spMk id="3" creationId="{00000000-0000-0000-0000-000000000000}"/>
+          </ac:spMkLst>
+        </pc:spChg>
+      </pc:sldChg>
+      <pc:sldChg chg="modSp mod">
+        <pc:chgData name="Robert Kresser" userId="6239b4f0b95ea466" providerId="LiveId" clId="{61C80E82-EC96-4668-A2AA-2AE0A88FD26E}" dt="2026-03-05T23:16:25.303" v="88" actId="13926"/>
+        <pc:sldMkLst>
+          <pc:docMk/>
+          <pc:sldMk cId="0" sldId="263"/>
+        </pc:sldMkLst>
+        <pc:spChg chg="mod">
+          <ac:chgData name="Robert Kresser" userId="6239b4f0b95ea466" providerId="LiveId" clId="{61C80E82-EC96-4668-A2AA-2AE0A88FD26E}" dt="2026-03-05T23:16:25.303" v="88" actId="13926"/>
+          <ac:spMkLst>
+            <pc:docMk/>
+            <pc:sldMk cId="0" sldId="263"/>
+            <ac:spMk id="3" creationId="{00000000-0000-0000-0000-000000000000}"/>
+          </ac:spMkLst>
+        </pc:spChg>
+      </pc:sldChg>
+    </pc:docChg>
+  </pc:docChgLst>
+</pc:chgInfo>
 </file>
 
 <file path=ppt/slideLayouts/slideLayout1.xml><?xml version="1.0" encoding="utf-8"?>
@@ -3614,13 +3658,10 @@
               <a:t>Accuracy: </a:t>
             </a:r>
             <a:r>
-              <a:rPr dirty="0">
-                <a:highlight>
-                  <a:srgbClr val="FFFF00"/>
-                </a:highlight>
-              </a:rPr>
-              <a:t>(Insert result)</a:t>
-            </a:r>
+              <a:rPr lang="en-US" dirty="0"/>
+              <a:t>0.9924</a:t>
+            </a:r>
+            <a:endParaRPr dirty="0"/>
           </a:p>
           <a:p>
             <a:r>
@@ -3628,13 +3669,10 @@
               <a:t>Observation: </a:t>
             </a:r>
             <a:r>
-              <a:rPr dirty="0">
-                <a:highlight>
-                  <a:srgbClr val="FFFF00"/>
-                </a:highlight>
-              </a:rPr>
-              <a:t>(Insert comparison)</a:t>
-            </a:r>
+              <a:rPr lang="en-US" dirty="0"/>
+              <a:t>Increased accuracy of .0041</a:t>
+            </a:r>
+            <a:endParaRPr dirty="0"/>
           </a:p>
         </p:txBody>
       </p:sp>
@@ -4153,21 +4191,17 @@
               <a:t>Variation 2 – Dropout: </a:t>
             </a:r>
             <a:r>
-              <a:rPr dirty="0">
-                <a:highlight>
-                  <a:srgbClr val="FFFF00"/>
-                </a:highlight>
-              </a:rPr>
-              <a:t>(Insert accuracy)</a:t>
-            </a:r>
-          </a:p>
-          <a:p>
-            <a:r>
-              <a:rPr dirty="0"/>
+              <a:rPr lang="en-US" dirty="0"/>
+              <a:t>0.9924</a:t>
+            </a:r>
+          </a:p>
+          <a:p>
+            <a:r>
+              <a:rPr lang="en-US" dirty="0"/>
               <a:t>Variation 3 – More Epochs: </a:t>
             </a:r>
             <a:r>
-              <a:rPr dirty="0">
+              <a:rPr lang="en-US" dirty="0">
                 <a:highlight>
                   <a:srgbClr val="FFFF00"/>
                 </a:highlight>

</xml_diff>

<commit_message>
Made my changes to the powerpoint, adding screenshots to the word doc. and chnaged line 42: Conv2D filters increased from 32 to 64
</commit_message>
<xml_diff>
--- a/IN501_Ridenour_Kresser_Meadows_Mpianin_Galarza_Unit9_Assignment.pptx
+++ b/IN501_Ridenour_Kresser_Meadows_Mpianin_Galarza_Unit9_Assignment.pptx
@@ -354,7 +354,7 @@
           <a:p>
             <a:fld id="{5BCAD085-E8A6-8845-BD4E-CB4CCA059FC4}" type="datetimeFigureOut">
               <a:rPr lang="en-US" smtClean="0"/>
-              <a:t>3/5/2026</a:t>
+              <a:t>3/9/2026</a:t>
             </a:fld>
             <a:endParaRPr lang="en-US"/>
           </a:p>
@@ -522,7 +522,7 @@
           <a:p>
             <a:fld id="{5BCAD085-E8A6-8845-BD4E-CB4CCA059FC4}" type="datetimeFigureOut">
               <a:rPr lang="en-US" smtClean="0"/>
-              <a:t>3/5/2026</a:t>
+              <a:t>3/9/2026</a:t>
             </a:fld>
             <a:endParaRPr lang="en-US"/>
           </a:p>
@@ -700,7 +700,7 @@
           <a:p>
             <a:fld id="{5BCAD085-E8A6-8845-BD4E-CB4CCA059FC4}" type="datetimeFigureOut">
               <a:rPr lang="en-US" smtClean="0"/>
-              <a:t>3/5/2026</a:t>
+              <a:t>3/9/2026</a:t>
             </a:fld>
             <a:endParaRPr lang="en-US"/>
           </a:p>
@@ -868,7 +868,7 @@
           <a:p>
             <a:fld id="{5BCAD085-E8A6-8845-BD4E-CB4CCA059FC4}" type="datetimeFigureOut">
               <a:rPr lang="en-US" smtClean="0"/>
-              <a:t>3/5/2026</a:t>
+              <a:t>3/9/2026</a:t>
             </a:fld>
             <a:endParaRPr lang="en-US"/>
           </a:p>
@@ -1113,7 +1113,7 @@
           <a:p>
             <a:fld id="{5BCAD085-E8A6-8845-BD4E-CB4CCA059FC4}" type="datetimeFigureOut">
               <a:rPr lang="en-US" smtClean="0"/>
-              <a:t>3/5/2026</a:t>
+              <a:t>3/9/2026</a:t>
             </a:fld>
             <a:endParaRPr lang="en-US"/>
           </a:p>
@@ -1398,7 +1398,7 @@
           <a:p>
             <a:fld id="{5BCAD085-E8A6-8845-BD4E-CB4CCA059FC4}" type="datetimeFigureOut">
               <a:rPr lang="en-US" smtClean="0"/>
-              <a:t>3/5/2026</a:t>
+              <a:t>3/9/2026</a:t>
             </a:fld>
             <a:endParaRPr lang="en-US"/>
           </a:p>
@@ -1817,7 +1817,7 @@
           <a:p>
             <a:fld id="{5BCAD085-E8A6-8845-BD4E-CB4CCA059FC4}" type="datetimeFigureOut">
               <a:rPr lang="en-US" smtClean="0"/>
-              <a:t>3/5/2026</a:t>
+              <a:t>3/9/2026</a:t>
             </a:fld>
             <a:endParaRPr lang="en-US"/>
           </a:p>
@@ -1934,7 +1934,7 @@
           <a:p>
             <a:fld id="{5BCAD085-E8A6-8845-BD4E-CB4CCA059FC4}" type="datetimeFigureOut">
               <a:rPr lang="en-US" smtClean="0"/>
-              <a:t>3/5/2026</a:t>
+              <a:t>3/9/2026</a:t>
             </a:fld>
             <a:endParaRPr lang="en-US"/>
           </a:p>
@@ -2029,7 +2029,7 @@
           <a:p>
             <a:fld id="{5BCAD085-E8A6-8845-BD4E-CB4CCA059FC4}" type="datetimeFigureOut">
               <a:rPr lang="en-US" smtClean="0"/>
-              <a:t>3/5/2026</a:t>
+              <a:t>3/9/2026</a:t>
             </a:fld>
             <a:endParaRPr lang="en-US"/>
           </a:p>
@@ -2304,7 +2304,7 @@
           <a:p>
             <a:fld id="{5BCAD085-E8A6-8845-BD4E-CB4CCA059FC4}" type="datetimeFigureOut">
               <a:rPr lang="en-US" smtClean="0"/>
-              <a:t>3/5/2026</a:t>
+              <a:t>3/9/2026</a:t>
             </a:fld>
             <a:endParaRPr lang="en-US"/>
           </a:p>
@@ -2556,7 +2556,7 @@
           <a:p>
             <a:fld id="{5BCAD085-E8A6-8845-BD4E-CB4CCA059FC4}" type="datetimeFigureOut">
               <a:rPr lang="en-US" smtClean="0"/>
-              <a:t>3/5/2026</a:t>
+              <a:t>3/9/2026</a:t>
             </a:fld>
             <a:endParaRPr lang="en-US"/>
           </a:p>
@@ -2767,7 +2767,7 @@
           <a:p>
             <a:fld id="{5BCAD085-E8A6-8845-BD4E-CB4CCA059FC4}" type="datetimeFigureOut">
               <a:rPr lang="en-US" smtClean="0"/>
-              <a:t>3/5/2026</a:t>
+              <a:t>3/9/2026</a:t>
             </a:fld>
             <a:endParaRPr lang="en-US"/>
           </a:p>
@@ -3516,30 +3516,32 @@
           <a:p>
             <a:r>
               <a:rPr dirty="0"/>
-              <a:t>Accuracy: </a:t>
-            </a:r>
-            <a:r>
-              <a:rPr dirty="0">
-                <a:highlight>
-                  <a:srgbClr val="FFFF00"/>
-                </a:highlight>
-              </a:rPr>
-              <a:t>(Insert result)</a:t>
-            </a:r>
-          </a:p>
-          <a:p>
-            <a:r>
-              <a:rPr dirty="0"/>
-              <a:t>Observation: </a:t>
-            </a:r>
-            <a:r>
-              <a:rPr dirty="0">
-                <a:highlight>
-                  <a:srgbClr val="FFFF00"/>
-                </a:highlight>
-              </a:rPr>
-              <a:t>(Insert comparison to baseline)</a:t>
-            </a:r>
+              <a:t>Accuracy:</a:t>
+            </a:r>
+            <a:r>
+              <a:rPr lang="en-US" dirty="0"/>
+              <a:t> 0.9907</a:t>
+            </a:r>
+            <a:endParaRPr dirty="0">
+              <a:highlight>
+                <a:srgbClr val="FFFF00"/>
+              </a:highlight>
+            </a:endParaRPr>
+          </a:p>
+          <a:p>
+            <a:r>
+              <a:rPr dirty="0"/>
+              <a:t>Observation</a:t>
+            </a:r>
+            <a:r>
+              <a:rPr lang="en-US" dirty="0"/>
+              <a:t>: Increased accuracy of 0.0024</a:t>
+            </a:r>
+            <a:endParaRPr dirty="0">
+              <a:highlight>
+                <a:srgbClr val="FFFF00"/>
+              </a:highlight>
+            </a:endParaRPr>
           </a:p>
         </p:txBody>
       </p:sp>

</xml_diff>

<commit_message>
Forgot to change one thing on a slide.
</commit_message>
<xml_diff>
--- a/IN501_Ridenour_Kresser_Meadows_Mpianin_Galarza_Unit9_Assignment.pptx
+++ b/IN501_Ridenour_Kresser_Meadows_Mpianin_Galarza_Unit9_Assignment.pptx
@@ -4176,16 +4176,13 @@
           <a:p>
             <a:r>
               <a:rPr lang="en-US" dirty="0"/>
-              <a:t>Variation 1 – Increased Filters: </a:t>
-            </a:r>
-            <a:r>
-              <a:rPr lang="en-US" dirty="0">
-                <a:highlight>
-                  <a:srgbClr val="FFFF00"/>
-                </a:highlight>
-              </a:rPr>
-              <a:t>(Insert accuracy)</a:t>
-            </a:r>
+              <a:t>Variation 1 – Increased Filters: 0.9907</a:t>
+            </a:r>
+            <a:endParaRPr lang="en-US" dirty="0">
+              <a:highlight>
+                <a:srgbClr val="FFFF00"/>
+              </a:highlight>
+            </a:endParaRPr>
           </a:p>
           <a:p>
             <a:r>

</xml_diff>

<commit_message>
Changed the theme of the powerpoint. Can revert back to original or something different I just wanted to spice it up a little bit.
</commit_message>
<xml_diff>
--- a/IN501_Ridenour_Kresser_Meadows_Mpianin_Galarza_Unit9_Assignment.pptx
+++ b/IN501_Ridenour_Kresser_Meadows_Mpianin_Galarza_Unit9_Assignment.pptx
@@ -2,7 +2,7 @@
 <file path=ppt/presentation.xml><?xml version="1.0" encoding="utf-8"?>
 <p:presentation xmlns:a="http://schemas.openxmlformats.org/drawingml/2006/main" xmlns:r="http://schemas.openxmlformats.org/officeDocument/2006/relationships" xmlns:p="http://schemas.openxmlformats.org/presentationml/2006/main" saveSubsetFonts="1" autoCompressPictures="0">
   <p:sldMasterIdLst>
-    <p:sldMasterId id="2147483648" r:id="rId1"/>
+    <p:sldMasterId id="2147483779" r:id="rId1"/>
   </p:sldMasterIdLst>
   <p:sldIdLst>
     <p:sldId id="256" r:id="rId2"/>
@@ -176,8 +176,18 @@
 </file>
 
 <file path=ppt/slideLayouts/slideLayout1.xml><?xml version="1.0" encoding="utf-8"?>
-<p:sldLayout xmlns:a="http://schemas.openxmlformats.org/drawingml/2006/main" xmlns:r="http://schemas.openxmlformats.org/officeDocument/2006/relationships" xmlns:p="http://schemas.openxmlformats.org/presentationml/2006/main" type="title" preserve="1">
+<p:sldLayout xmlns:a="http://schemas.openxmlformats.org/drawingml/2006/main" xmlns:r="http://schemas.openxmlformats.org/officeDocument/2006/relationships" xmlns:p="http://schemas.openxmlformats.org/presentationml/2006/main" showMasterSp="0" type="title" preserve="1">
   <p:cSld name="Title Slide">
+    <p:bg>
+      <p:bgPr>
+        <a:solidFill>
+          <a:schemeClr val="bg2">
+            <a:lumMod val="75000"/>
+          </a:schemeClr>
+        </a:solidFill>
+        <a:effectLst/>
+      </p:bgPr>
+    </p:bg>
     <p:spTree>
       <p:nvGrpSpPr>
         <p:cNvPr id="1" name=""/>
@@ -204,18 +214,32 @@
         </p:nvSpPr>
         <p:spPr>
           <a:xfrm>
-            <a:off x="685800" y="2130425"/>
-            <a:ext cx="7772400" cy="1470025"/>
+            <a:off x="946404" y="758952"/>
+            <a:ext cx="7063740" cy="4041648"/>
           </a:xfrm>
         </p:spPr>
         <p:txBody>
-          <a:bodyPr/>
-          <a:lstStyle/>
+          <a:bodyPr anchor="b">
+            <a:normAutofit/>
+          </a:bodyPr>
+          <a:lstStyle>
+            <a:lvl1pPr algn="l">
+              <a:lnSpc>
+                <a:spcPct val="85000"/>
+              </a:lnSpc>
+              <a:defRPr sz="6600" baseline="0">
+                <a:solidFill>
+                  <a:schemeClr val="tx1"/>
+                </a:solidFill>
+              </a:defRPr>
+            </a:lvl1pPr>
+          </a:lstStyle>
           <a:p>
             <a:r>
               <a:rPr lang="en-US"/>
               <a:t>Click to edit Master title style</a:t>
             </a:r>
+            <a:endParaRPr lang="en-US" dirty="0"/>
           </a:p>
         </p:txBody>
       </p:sp>
@@ -231,126 +255,130 @@
         </p:nvSpPr>
         <p:spPr>
           <a:xfrm>
-            <a:off x="1371600" y="3886200"/>
-            <a:ext cx="6400800" cy="1752600"/>
+            <a:off x="946404" y="4800600"/>
+            <a:ext cx="7063740" cy="1691640"/>
           </a:xfrm>
         </p:spPr>
         <p:txBody>
-          <a:bodyPr/>
+          <a:bodyPr>
+            <a:normAutofit/>
+          </a:bodyPr>
           <a:lstStyle>
-            <a:lvl1pPr marL="0" indent="0" algn="ctr">
-              <a:buNone/>
-              <a:defRPr>
+            <a:lvl1pPr marL="0" indent="0" algn="l">
+              <a:buNone/>
+              <a:defRPr sz="2000" baseline="0">
                 <a:solidFill>
                   <a:schemeClr val="tx1">
-                    <a:tint val="75000"/>
+                    <a:lumMod val="85000"/>
                   </a:schemeClr>
                 </a:solidFill>
               </a:defRPr>
             </a:lvl1pPr>
             <a:lvl2pPr marL="457200" indent="0" algn="ctr">
               <a:buNone/>
+              <a:defRPr sz="2000"/>
+            </a:lvl2pPr>
+            <a:lvl3pPr marL="914400" indent="0" algn="ctr">
+              <a:buNone/>
+              <a:defRPr sz="2000"/>
+            </a:lvl3pPr>
+            <a:lvl4pPr marL="1371600" indent="0" algn="ctr">
+              <a:buNone/>
+              <a:defRPr sz="2000"/>
+            </a:lvl4pPr>
+            <a:lvl5pPr marL="1828800" indent="0" algn="ctr">
+              <a:buNone/>
+              <a:defRPr sz="2000"/>
+            </a:lvl5pPr>
+            <a:lvl6pPr marL="2286000" indent="0" algn="ctr">
+              <a:buNone/>
+              <a:defRPr sz="2000"/>
+            </a:lvl6pPr>
+            <a:lvl7pPr marL="2743200" indent="0" algn="ctr">
+              <a:buNone/>
+              <a:defRPr sz="2000"/>
+            </a:lvl7pPr>
+            <a:lvl8pPr marL="3200400" indent="0" algn="ctr">
+              <a:buNone/>
+              <a:defRPr sz="2000"/>
+            </a:lvl8pPr>
+            <a:lvl9pPr marL="3657600" indent="0" algn="ctr">
+              <a:buNone/>
+              <a:defRPr sz="2000"/>
+            </a:lvl9pPr>
+          </a:lstStyle>
+          <a:p>
+            <a:r>
+              <a:rPr lang="en-US"/>
+              <a:t>Click to edit Master subtitle style</a:t>
+            </a:r>
+            <a:endParaRPr lang="en-US" dirty="0"/>
+          </a:p>
+        </p:txBody>
+      </p:sp>
+      <p:sp>
+        <p:nvSpPr>
+          <p:cNvPr id="7" name="Rectangle 6"/>
+          <p:cNvSpPr/>
+          <p:nvPr/>
+        </p:nvSpPr>
+        <p:spPr>
+          <a:xfrm>
+            <a:off x="0" y="0"/>
+            <a:ext cx="342900" cy="6858000"/>
+          </a:xfrm>
+          <a:prstGeom prst="rect">
+            <a:avLst/>
+          </a:prstGeom>
+          <a:solidFill>
+            <a:schemeClr val="accent1"/>
+          </a:solidFill>
+          <a:ln>
+            <a:noFill/>
+          </a:ln>
+        </p:spPr>
+        <p:style>
+          <a:lnRef idx="2">
+            <a:schemeClr val="accent1">
+              <a:shade val="50000"/>
+            </a:schemeClr>
+          </a:lnRef>
+          <a:fillRef idx="1">
+            <a:schemeClr val="accent1"/>
+          </a:fillRef>
+          <a:effectRef idx="0">
+            <a:schemeClr val="accent1"/>
+          </a:effectRef>
+          <a:fontRef idx="minor">
+            <a:schemeClr val="lt1"/>
+          </a:fontRef>
+        </p:style>
+      </p:sp>
+      <p:sp>
+        <p:nvSpPr>
+          <p:cNvPr id="8" name="Date Placeholder 7"/>
+          <p:cNvSpPr>
+            <a:spLocks noGrp="1"/>
+          </p:cNvSpPr>
+          <p:nvPr>
+            <p:ph type="dt" sz="half" idx="10"/>
+          </p:nvPr>
+        </p:nvSpPr>
+        <p:spPr/>
+        <p:txBody>
+          <a:bodyPr/>
+          <a:lstStyle>
+            <a:lvl1pPr>
               <a:defRPr>
                 <a:solidFill>
-                  <a:schemeClr val="tx1">
-                    <a:tint val="75000"/>
+                  <a:schemeClr val="bg2">
+                    <a:lumMod val="20000"/>
+                    <a:lumOff val="80000"/>
                   </a:schemeClr>
                 </a:solidFill>
               </a:defRPr>
-            </a:lvl2pPr>
-            <a:lvl3pPr marL="914400" indent="0" algn="ctr">
-              <a:buNone/>
-              <a:defRPr>
-                <a:solidFill>
-                  <a:schemeClr val="tx1">
-                    <a:tint val="75000"/>
-                  </a:schemeClr>
-                </a:solidFill>
-              </a:defRPr>
-            </a:lvl3pPr>
-            <a:lvl4pPr marL="1371600" indent="0" algn="ctr">
-              <a:buNone/>
-              <a:defRPr>
-                <a:solidFill>
-                  <a:schemeClr val="tx1">
-                    <a:tint val="75000"/>
-                  </a:schemeClr>
-                </a:solidFill>
-              </a:defRPr>
-            </a:lvl4pPr>
-            <a:lvl5pPr marL="1828800" indent="0" algn="ctr">
-              <a:buNone/>
-              <a:defRPr>
-                <a:solidFill>
-                  <a:schemeClr val="tx1">
-                    <a:tint val="75000"/>
-                  </a:schemeClr>
-                </a:solidFill>
-              </a:defRPr>
-            </a:lvl5pPr>
-            <a:lvl6pPr marL="2286000" indent="0" algn="ctr">
-              <a:buNone/>
-              <a:defRPr>
-                <a:solidFill>
-                  <a:schemeClr val="tx1">
-                    <a:tint val="75000"/>
-                  </a:schemeClr>
-                </a:solidFill>
-              </a:defRPr>
-            </a:lvl6pPr>
-            <a:lvl7pPr marL="2743200" indent="0" algn="ctr">
-              <a:buNone/>
-              <a:defRPr>
-                <a:solidFill>
-                  <a:schemeClr val="tx1">
-                    <a:tint val="75000"/>
-                  </a:schemeClr>
-                </a:solidFill>
-              </a:defRPr>
-            </a:lvl7pPr>
-            <a:lvl8pPr marL="3200400" indent="0" algn="ctr">
-              <a:buNone/>
-              <a:defRPr>
-                <a:solidFill>
-                  <a:schemeClr val="tx1">
-                    <a:tint val="75000"/>
-                  </a:schemeClr>
-                </a:solidFill>
-              </a:defRPr>
-            </a:lvl8pPr>
-            <a:lvl9pPr marL="3657600" indent="0" algn="ctr">
-              <a:buNone/>
-              <a:defRPr>
-                <a:solidFill>
-                  <a:schemeClr val="tx1">
-                    <a:tint val="75000"/>
-                  </a:schemeClr>
-                </a:solidFill>
-              </a:defRPr>
-            </a:lvl9pPr>
+            </a:lvl1pPr>
           </a:lstStyle>
-          <a:p>
-            <a:r>
-              <a:rPr lang="en-US"/>
-              <a:t>Click to edit Master subtitle style</a:t>
-            </a:r>
-          </a:p>
-        </p:txBody>
-      </p:sp>
-      <p:sp>
-        <p:nvSpPr>
-          <p:cNvPr id="4" name="Date Placeholder 3"/>
-          <p:cNvSpPr>
-            <a:spLocks noGrp="1"/>
-          </p:cNvSpPr>
-          <p:nvPr>
-            <p:ph type="dt" sz="half" idx="10"/>
-          </p:nvPr>
-        </p:nvSpPr>
-        <p:spPr/>
-        <p:txBody>
-          <a:bodyPr/>
-          <a:lstStyle/>
           <a:p>
             <a:fld id="{5BCAD085-E8A6-8845-BD4E-CB4CCA059FC4}" type="datetimeFigureOut">
               <a:rPr lang="en-US" smtClean="0"/>
@@ -362,7 +390,7 @@
       </p:sp>
       <p:sp>
         <p:nvSpPr>
-          <p:cNvPr id="5" name="Footer Placeholder 4"/>
+          <p:cNvPr id="9" name="Footer Placeholder 8"/>
           <p:cNvSpPr>
             <a:spLocks noGrp="1"/>
           </p:cNvSpPr>
@@ -373,7 +401,18 @@
         <p:spPr/>
         <p:txBody>
           <a:bodyPr/>
-          <a:lstStyle/>
+          <a:lstStyle>
+            <a:lvl1pPr>
+              <a:defRPr>
+                <a:solidFill>
+                  <a:schemeClr val="bg2">
+                    <a:lumMod val="20000"/>
+                    <a:lumOff val="80000"/>
+                  </a:schemeClr>
+                </a:solidFill>
+              </a:defRPr>
+            </a:lvl1pPr>
+          </a:lstStyle>
           <a:p>
             <a:endParaRPr lang="en-US"/>
           </a:p>
@@ -381,7 +420,7 @@
       </p:sp>
       <p:sp>
         <p:nvSpPr>
-          <p:cNvPr id="6" name="Slide Number Placeholder 5"/>
+          <p:cNvPr id="10" name="Slide Number Placeholder 9"/>
           <p:cNvSpPr>
             <a:spLocks noGrp="1"/>
           </p:cNvSpPr>
@@ -392,7 +431,18 @@
         <p:spPr/>
         <p:txBody>
           <a:bodyPr/>
-          <a:lstStyle/>
+          <a:lstStyle>
+            <a:lvl1pPr>
+              <a:defRPr>
+                <a:solidFill>
+                  <a:schemeClr val="bg2">
+                    <a:lumMod val="60000"/>
+                    <a:lumOff val="40000"/>
+                  </a:schemeClr>
+                </a:solidFill>
+              </a:defRPr>
+            </a:lvl1pPr>
+          </a:lstStyle>
           <a:p>
             <a:fld id="{C1FF6DA9-008F-8B48-92A6-B652298478BF}" type="slidenum">
               <a:rPr lang="en-US" smtClean="0"/>
@@ -405,12 +455,12 @@
     </p:spTree>
     <p:extLst>
       <p:ext uri="{BB962C8B-B14F-4D97-AF65-F5344CB8AC3E}">
-        <p14:creationId xmlns:p14="http://schemas.microsoft.com/office/powerpoint/2010/main" val="3168075583"/>
+        <p14:creationId xmlns:p14="http://schemas.microsoft.com/office/powerpoint/2010/main" val="3224976508"/>
       </p:ext>
     </p:extLst>
   </p:cSld>
   <p:clrMapOvr>
-    <a:masterClrMapping/>
+    <a:overrideClrMapping bg1="dk1" tx1="lt1" bg2="dk2" tx2="lt2" accent1="accent1" accent2="accent2" accent3="accent3" accent4="accent4" accent5="accent5" accent6="accent6" hlink="hlink" folHlink="folHlink"/>
   </p:clrMapOvr>
 </p:sldLayout>
 </file>
@@ -451,6 +501,7 @@
               <a:rPr lang="en-US"/>
               <a:t>Click to edit Master title style</a:t>
             </a:r>
+            <a:endParaRPr lang="en-US" dirty="0"/>
           </a:p>
         </p:txBody>
       </p:sp>
@@ -502,6 +553,7 @@
               <a:rPr lang="en-US"/>
               <a:t>Fifth level</a:t>
             </a:r>
+            <a:endParaRPr lang="en-US" dirty="0"/>
           </a:p>
         </p:txBody>
       </p:sp>
@@ -573,7 +625,7 @@
     </p:spTree>
     <p:extLst>
       <p:ext uri="{BB962C8B-B14F-4D97-AF65-F5344CB8AC3E}">
-        <p14:creationId xmlns:p14="http://schemas.microsoft.com/office/powerpoint/2010/main" val="2910927964"/>
+        <p14:creationId xmlns:p14="http://schemas.microsoft.com/office/powerpoint/2010/main" val="671876378"/>
       </p:ext>
     </p:extLst>
   </p:cSld>
@@ -612,8 +664,8 @@
         </p:nvSpPr>
         <p:spPr>
           <a:xfrm>
-            <a:off x="6629400" y="274638"/>
-            <a:ext cx="2057400" cy="5851525"/>
+            <a:off x="6486525" y="381000"/>
+            <a:ext cx="1857375" cy="5897562"/>
           </a:xfrm>
         </p:spPr>
         <p:txBody>
@@ -624,6 +676,7 @@
               <a:rPr lang="en-US"/>
               <a:t>Click to edit Master title style</a:t>
             </a:r>
+            <a:endParaRPr lang="en-US" dirty="0"/>
           </a:p>
         </p:txBody>
       </p:sp>
@@ -639,8 +692,8 @@
         </p:nvSpPr>
         <p:spPr>
           <a:xfrm>
-            <a:off x="457200" y="274638"/>
-            <a:ext cx="6019800" cy="5851525"/>
+            <a:off x="571500" y="381000"/>
+            <a:ext cx="5800725" cy="5897562"/>
           </a:xfrm>
         </p:spPr>
         <p:txBody>
@@ -680,6 +733,7 @@
               <a:rPr lang="en-US"/>
               <a:t>Fifth level</a:t>
             </a:r>
+            <a:endParaRPr lang="en-US" dirty="0"/>
           </a:p>
         </p:txBody>
       </p:sp>
@@ -751,7 +805,7 @@
     </p:spTree>
     <p:extLst>
       <p:ext uri="{BB962C8B-B14F-4D97-AF65-F5344CB8AC3E}">
-        <p14:creationId xmlns:p14="http://schemas.microsoft.com/office/powerpoint/2010/main" val="3612223792"/>
+        <p14:creationId xmlns:p14="http://schemas.microsoft.com/office/powerpoint/2010/main" val="2448014345"/>
       </p:ext>
     </p:extLst>
   </p:cSld>
@@ -797,6 +851,7 @@
               <a:rPr lang="en-US"/>
               <a:t>Click to edit Master title style</a:t>
             </a:r>
+            <a:endParaRPr lang="en-US" dirty="0"/>
           </a:p>
         </p:txBody>
       </p:sp>
@@ -848,6 +903,7 @@
               <a:rPr lang="en-US"/>
               <a:t>Fifth level</a:t>
             </a:r>
+            <a:endParaRPr lang="en-US" dirty="0"/>
           </a:p>
         </p:txBody>
       </p:sp>
@@ -919,7 +975,7 @@
     </p:spTree>
     <p:extLst>
       <p:ext uri="{BB962C8B-B14F-4D97-AF65-F5344CB8AC3E}">
-        <p14:creationId xmlns:p14="http://schemas.microsoft.com/office/powerpoint/2010/main" val="2614314258"/>
+        <p14:creationId xmlns:p14="http://schemas.microsoft.com/office/powerpoint/2010/main" val="2020180874"/>
       </p:ext>
     </p:extLst>
   </p:cSld>
@@ -958,15 +1014,20 @@
         </p:nvSpPr>
         <p:spPr>
           <a:xfrm>
-            <a:off x="722313" y="4406900"/>
-            <a:ext cx="7772400" cy="1362075"/>
+            <a:off x="946404" y="758952"/>
+            <a:ext cx="7063740" cy="4041648"/>
           </a:xfrm>
         </p:spPr>
         <p:txBody>
-          <a:bodyPr anchor="t"/>
+          <a:bodyPr anchor="b">
+            <a:normAutofit/>
+          </a:bodyPr>
           <a:lstStyle>
-            <a:lvl1pPr algn="l">
-              <a:defRPr sz="4000" b="1" cap="all"/>
+            <a:lvl1pPr>
+              <a:lnSpc>
+                <a:spcPct val="85000"/>
+              </a:lnSpc>
+              <a:defRPr sz="6600" b="0"/>
             </a:lvl1pPr>
           </a:lstStyle>
           <a:p>
@@ -974,6 +1035,7 @@
               <a:rPr lang="en-US"/>
               <a:t>Click to edit Master title style</a:t>
             </a:r>
+            <a:endParaRPr lang="en-US" dirty="0"/>
           </a:p>
         </p:txBody>
       </p:sp>
@@ -989,19 +1051,22 @@
         </p:nvSpPr>
         <p:spPr>
           <a:xfrm>
-            <a:off x="722313" y="2906713"/>
-            <a:ext cx="7772400" cy="1500187"/>
+            <a:off x="946404" y="4800600"/>
+            <a:ext cx="7063740" cy="1691640"/>
           </a:xfrm>
         </p:spPr>
         <p:txBody>
-          <a:bodyPr anchor="b"/>
+          <a:bodyPr anchor="t">
+            <a:normAutofit/>
+          </a:bodyPr>
           <a:lstStyle>
             <a:lvl1pPr marL="0" indent="0">
               <a:buNone/>
               <a:defRPr sz="2000">
                 <a:solidFill>
                   <a:schemeClr val="tx1">
-                    <a:tint val="75000"/>
+                    <a:lumMod val="75000"/>
+                    <a:lumOff val="25000"/>
                   </a:schemeClr>
                 </a:solidFill>
               </a:defRPr>
@@ -1161,10 +1226,48 @@
           </a:p>
         </p:txBody>
       </p:sp>
+      <p:sp>
+        <p:nvSpPr>
+          <p:cNvPr id="7" name="Rectangle 6"/>
+          <p:cNvSpPr/>
+          <p:nvPr/>
+        </p:nvSpPr>
+        <p:spPr>
+          <a:xfrm>
+            <a:off x="0" y="0"/>
+            <a:ext cx="342900" cy="6858000"/>
+          </a:xfrm>
+          <a:prstGeom prst="rect">
+            <a:avLst/>
+          </a:prstGeom>
+          <a:solidFill>
+            <a:schemeClr val="accent1"/>
+          </a:solidFill>
+          <a:ln>
+            <a:noFill/>
+          </a:ln>
+        </p:spPr>
+        <p:style>
+          <a:lnRef idx="2">
+            <a:schemeClr val="accent1">
+              <a:shade val="50000"/>
+            </a:schemeClr>
+          </a:lnRef>
+          <a:fillRef idx="1">
+            <a:schemeClr val="accent1"/>
+          </a:fillRef>
+          <a:effectRef idx="0">
+            <a:schemeClr val="accent1"/>
+          </a:effectRef>
+          <a:fontRef idx="minor">
+            <a:schemeClr val="lt1"/>
+          </a:fontRef>
+        </p:style>
+      </p:sp>
     </p:spTree>
     <p:extLst>
       <p:ext uri="{BB962C8B-B14F-4D97-AF65-F5344CB8AC3E}">
-        <p14:creationId xmlns:p14="http://schemas.microsoft.com/office/powerpoint/2010/main" val="960648375"/>
+        <p14:creationId xmlns:p14="http://schemas.microsoft.com/office/powerpoint/2010/main" val="1560291848"/>
       </p:ext>
     </p:extLst>
   </p:cSld>
@@ -1210,6 +1313,7 @@
               <a:rPr lang="en-US"/>
               <a:t>Click to edit Master title style</a:t>
             </a:r>
+            <a:endParaRPr lang="en-US" dirty="0"/>
           </a:p>
         </p:txBody>
       </p:sp>
@@ -1225,39 +1329,39 @@
         </p:nvSpPr>
         <p:spPr>
           <a:xfrm>
-            <a:off x="457200" y="1600200"/>
-            <a:ext cx="4038600" cy="4525963"/>
+            <a:off x="946404" y="1828801"/>
+            <a:ext cx="3360420" cy="4351337"/>
           </a:xfrm>
         </p:spPr>
         <p:txBody>
           <a:bodyPr/>
           <a:lstStyle>
             <a:lvl1pPr>
-              <a:defRPr sz="2800"/>
+              <a:defRPr sz="1800"/>
             </a:lvl1pPr>
             <a:lvl2pPr>
-              <a:defRPr sz="2400"/>
+              <a:defRPr sz="1600"/>
             </a:lvl2pPr>
             <a:lvl3pPr>
-              <a:defRPr sz="2000"/>
+              <a:defRPr sz="1400"/>
             </a:lvl3pPr>
             <a:lvl4pPr>
-              <a:defRPr sz="1800"/>
+              <a:defRPr sz="1400"/>
             </a:lvl4pPr>
             <a:lvl5pPr>
-              <a:defRPr sz="1800"/>
+              <a:defRPr sz="1400"/>
             </a:lvl5pPr>
             <a:lvl6pPr>
-              <a:defRPr sz="1800"/>
+              <a:defRPr sz="1400"/>
             </a:lvl6pPr>
             <a:lvl7pPr>
-              <a:defRPr sz="1800"/>
+              <a:defRPr sz="1400"/>
             </a:lvl7pPr>
             <a:lvl8pPr>
-              <a:defRPr sz="1800"/>
+              <a:defRPr sz="1400"/>
             </a:lvl8pPr>
             <a:lvl9pPr>
-              <a:defRPr sz="1800"/>
+              <a:defRPr sz="1400"/>
             </a:lvl9pPr>
           </a:lstStyle>
           <a:p>
@@ -1294,6 +1398,7 @@
               <a:rPr lang="en-US"/>
               <a:t>Fifth level</a:t>
             </a:r>
+            <a:endParaRPr lang="en-US" dirty="0"/>
           </a:p>
         </p:txBody>
       </p:sp>
@@ -1309,39 +1414,39 @@
         </p:nvSpPr>
         <p:spPr>
           <a:xfrm>
-            <a:off x="4648200" y="1600200"/>
-            <a:ext cx="4038600" cy="4525963"/>
+            <a:off x="4594860" y="1828801"/>
+            <a:ext cx="3360420" cy="4351337"/>
           </a:xfrm>
         </p:spPr>
         <p:txBody>
           <a:bodyPr/>
           <a:lstStyle>
             <a:lvl1pPr>
-              <a:defRPr sz="2800"/>
+              <a:defRPr sz="1800"/>
             </a:lvl1pPr>
             <a:lvl2pPr>
-              <a:defRPr sz="2400"/>
+              <a:defRPr sz="1600"/>
             </a:lvl2pPr>
             <a:lvl3pPr>
-              <a:defRPr sz="2000"/>
+              <a:defRPr sz="1400"/>
             </a:lvl3pPr>
             <a:lvl4pPr>
-              <a:defRPr sz="1800"/>
+              <a:defRPr sz="1400"/>
             </a:lvl4pPr>
             <a:lvl5pPr>
-              <a:defRPr sz="1800"/>
+              <a:defRPr sz="1400"/>
             </a:lvl5pPr>
             <a:lvl6pPr>
-              <a:defRPr sz="1800"/>
+              <a:defRPr sz="1400"/>
             </a:lvl6pPr>
             <a:lvl7pPr>
-              <a:defRPr sz="1800"/>
+              <a:defRPr sz="1400"/>
             </a:lvl7pPr>
             <a:lvl8pPr>
-              <a:defRPr sz="1800"/>
+              <a:defRPr sz="1400"/>
             </a:lvl8pPr>
             <a:lvl9pPr>
-              <a:defRPr sz="1800"/>
+              <a:defRPr sz="1400"/>
             </a:lvl9pPr>
           </a:lstStyle>
           <a:p>
@@ -1378,6 +1483,7 @@
               <a:rPr lang="en-US"/>
               <a:t>Fifth level</a:t>
             </a:r>
+            <a:endParaRPr lang="en-US" dirty="0"/>
           </a:p>
         </p:txBody>
       </p:sp>
@@ -1449,7 +1555,7 @@
     </p:spTree>
     <p:extLst>
       <p:ext uri="{BB962C8B-B14F-4D97-AF65-F5344CB8AC3E}">
-        <p14:creationId xmlns:p14="http://schemas.microsoft.com/office/powerpoint/2010/main" val="2782244947"/>
+        <p14:creationId xmlns:p14="http://schemas.microsoft.com/office/powerpoint/2010/main" val="1797305671"/>
       </p:ext>
     </p:extLst>
   </p:cSld>
@@ -1478,7 +1584,7 @@
       </p:grpSpPr>
       <p:sp>
         <p:nvSpPr>
-          <p:cNvPr id="2" name="Title 1"/>
+          <p:cNvPr id="10" name="Title 9"/>
           <p:cNvSpPr>
             <a:spLocks noGrp="1"/>
           </p:cNvSpPr>
@@ -1487,131 +1593,280 @@
           </p:nvPr>
         </p:nvSpPr>
         <p:spPr/>
+        <p:txBody>
+          <a:bodyPr/>
+          <a:lstStyle/>
+          <a:p>
+            <a:r>
+              <a:rPr lang="en-US"/>
+              <a:t>Click to edit Master title style</a:t>
+            </a:r>
+            <a:endParaRPr lang="en-US" dirty="0"/>
+          </a:p>
+        </p:txBody>
+      </p:sp>
+      <p:sp>
+        <p:nvSpPr>
+          <p:cNvPr id="3" name="Text Placeholder 2"/>
+          <p:cNvSpPr>
+            <a:spLocks noGrp="1"/>
+          </p:cNvSpPr>
+          <p:nvPr>
+            <p:ph type="body" idx="1"/>
+          </p:nvPr>
+        </p:nvSpPr>
+        <p:spPr>
+          <a:xfrm>
+            <a:off x="946404" y="1717185"/>
+            <a:ext cx="3360420" cy="731520"/>
+          </a:xfrm>
+        </p:spPr>
+        <p:txBody>
+          <a:bodyPr anchor="b">
+            <a:normAutofit/>
+          </a:bodyPr>
+          <a:lstStyle>
+            <a:lvl1pPr marL="0" indent="0">
+              <a:spcBef>
+                <a:spcPts val="0"/>
+              </a:spcBef>
+              <a:buNone/>
+              <a:defRPr sz="1800" b="0">
+                <a:solidFill>
+                  <a:schemeClr val="tx2"/>
+                </a:solidFill>
+              </a:defRPr>
+            </a:lvl1pPr>
+            <a:lvl2pPr marL="457200" indent="0">
+              <a:buNone/>
+              <a:defRPr sz="1800" b="1"/>
+            </a:lvl2pPr>
+            <a:lvl3pPr marL="914400" indent="0">
+              <a:buNone/>
+              <a:defRPr sz="1800" b="1"/>
+            </a:lvl3pPr>
+            <a:lvl4pPr marL="1371600" indent="0">
+              <a:buNone/>
+              <a:defRPr sz="1600" b="1"/>
+            </a:lvl4pPr>
+            <a:lvl5pPr marL="1828800" indent="0">
+              <a:buNone/>
+              <a:defRPr sz="1600" b="1"/>
+            </a:lvl5pPr>
+            <a:lvl6pPr marL="2286000" indent="0">
+              <a:buNone/>
+              <a:defRPr sz="1600" b="1"/>
+            </a:lvl6pPr>
+            <a:lvl7pPr marL="2743200" indent="0">
+              <a:buNone/>
+              <a:defRPr sz="1600" b="1"/>
+            </a:lvl7pPr>
+            <a:lvl8pPr marL="3200400" indent="0">
+              <a:buNone/>
+              <a:defRPr sz="1600" b="1"/>
+            </a:lvl8pPr>
+            <a:lvl9pPr marL="3657600" indent="0">
+              <a:buNone/>
+              <a:defRPr sz="1600" b="1"/>
+            </a:lvl9pPr>
+          </a:lstStyle>
+          <a:p>
+            <a:pPr lvl="0"/>
+            <a:r>
+              <a:rPr lang="en-US"/>
+              <a:t>Click to edit Master text styles</a:t>
+            </a:r>
+          </a:p>
+        </p:txBody>
+      </p:sp>
+      <p:sp>
+        <p:nvSpPr>
+          <p:cNvPr id="4" name="Content Placeholder 3"/>
+          <p:cNvSpPr>
+            <a:spLocks noGrp="1"/>
+          </p:cNvSpPr>
+          <p:nvPr>
+            <p:ph sz="half" idx="2"/>
+          </p:nvPr>
+        </p:nvSpPr>
+        <p:spPr>
+          <a:xfrm>
+            <a:off x="946404" y="2507550"/>
+            <a:ext cx="3360420" cy="3664650"/>
+          </a:xfrm>
+        </p:spPr>
         <p:txBody>
           <a:bodyPr/>
           <a:lstStyle>
             <a:lvl1pPr>
-              <a:defRPr/>
+              <a:defRPr sz="1800"/>
+            </a:lvl1pPr>
+            <a:lvl2pPr>
+              <a:defRPr sz="1600"/>
+            </a:lvl2pPr>
+            <a:lvl3pPr>
+              <a:defRPr sz="1400"/>
+            </a:lvl3pPr>
+            <a:lvl4pPr>
+              <a:defRPr sz="1400"/>
+            </a:lvl4pPr>
+            <a:lvl5pPr>
+              <a:defRPr sz="1400"/>
+            </a:lvl5pPr>
+            <a:lvl6pPr>
+              <a:defRPr sz="1400"/>
+            </a:lvl6pPr>
+            <a:lvl7pPr>
+              <a:defRPr sz="1400"/>
+            </a:lvl7pPr>
+            <a:lvl8pPr>
+              <a:defRPr sz="1400"/>
+            </a:lvl8pPr>
+            <a:lvl9pPr>
+              <a:defRPr sz="1400"/>
+            </a:lvl9pPr>
+          </a:lstStyle>
+          <a:p>
+            <a:pPr lvl="0"/>
+            <a:r>
+              <a:rPr lang="en-US"/>
+              <a:t>Click to edit Master text styles</a:t>
+            </a:r>
+          </a:p>
+          <a:p>
+            <a:pPr lvl="1"/>
+            <a:r>
+              <a:rPr lang="en-US"/>
+              <a:t>Second level</a:t>
+            </a:r>
+          </a:p>
+          <a:p>
+            <a:pPr lvl="2"/>
+            <a:r>
+              <a:rPr lang="en-US"/>
+              <a:t>Third level</a:t>
+            </a:r>
+          </a:p>
+          <a:p>
+            <a:pPr lvl="3"/>
+            <a:r>
+              <a:rPr lang="en-US"/>
+              <a:t>Fourth level</a:t>
+            </a:r>
+          </a:p>
+          <a:p>
+            <a:pPr lvl="4"/>
+            <a:r>
+              <a:rPr lang="en-US"/>
+              <a:t>Fifth level</a:t>
+            </a:r>
+            <a:endParaRPr lang="en-US" dirty="0"/>
+          </a:p>
+        </p:txBody>
+      </p:sp>
+      <p:sp>
+        <p:nvSpPr>
+          <p:cNvPr id="11" name="Text Placeholder 10"/>
+          <p:cNvSpPr>
+            <a:spLocks noGrp="1"/>
+          </p:cNvSpPr>
+          <p:nvPr>
+            <p:ph type="body" sz="quarter" idx="13"/>
+          </p:nvPr>
+        </p:nvSpPr>
+        <p:spPr>
+          <a:xfrm>
+            <a:off x="4599432" y="1717185"/>
+            <a:ext cx="3364992" cy="731520"/>
+          </a:xfrm>
+        </p:spPr>
+        <p:txBody>
+          <a:bodyPr anchor="b">
+            <a:normAutofit/>
+          </a:bodyPr>
+          <a:lstStyle>
+            <a:lvl1pPr marL="0" indent="0">
+              <a:buFontTx/>
+              <a:buNone/>
+              <a:defRPr lang="en-US" sz="1800" b="0" kern="1200" spc="10" baseline="0" dirty="0">
+                <a:solidFill>
+                  <a:schemeClr val="tx2"/>
+                </a:solidFill>
+                <a:latin typeface="+mn-lt"/>
+                <a:ea typeface="+mn-ea"/>
+                <a:cs typeface="+mn-cs"/>
+              </a:defRPr>
             </a:lvl1pPr>
           </a:lstStyle>
           <a:p>
-            <a:r>
-              <a:rPr lang="en-US"/>
-              <a:t>Click to edit Master title style</a:t>
-            </a:r>
-          </a:p>
-        </p:txBody>
-      </p:sp>
-      <p:sp>
-        <p:nvSpPr>
-          <p:cNvPr id="3" name="Text Placeholder 2"/>
-          <p:cNvSpPr>
-            <a:spLocks noGrp="1"/>
-          </p:cNvSpPr>
-          <p:nvPr>
-            <p:ph type="body" idx="1"/>
+            <a:pPr marL="0" lvl="0" indent="0" algn="l" defTabSz="914400" rtl="0" eaLnBrk="1" latinLnBrk="0" hangingPunct="1">
+              <a:lnSpc>
+                <a:spcPct val="95000"/>
+              </a:lnSpc>
+              <a:spcBef>
+                <a:spcPts val="0"/>
+              </a:spcBef>
+              <a:spcAft>
+                <a:spcPts val="200"/>
+              </a:spcAft>
+              <a:buClr>
+                <a:schemeClr val="accent1"/>
+              </a:buClr>
+              <a:buSzPct val="80000"/>
+              <a:buNone/>
+            </a:pPr>
+            <a:r>
+              <a:rPr lang="en-US"/>
+              <a:t>Click to edit Master text styles</a:t>
+            </a:r>
+          </a:p>
+        </p:txBody>
+      </p:sp>
+      <p:sp>
+        <p:nvSpPr>
+          <p:cNvPr id="6" name="Content Placeholder 5"/>
+          <p:cNvSpPr>
+            <a:spLocks noGrp="1"/>
+          </p:cNvSpPr>
+          <p:nvPr>
+            <p:ph sz="quarter" idx="4"/>
           </p:nvPr>
         </p:nvSpPr>
         <p:spPr>
           <a:xfrm>
-            <a:off x="457200" y="1535113"/>
-            <a:ext cx="4040188" cy="639762"/>
-          </a:xfrm>
-        </p:spPr>
-        <p:txBody>
-          <a:bodyPr anchor="b"/>
-          <a:lstStyle>
-            <a:lvl1pPr marL="0" indent="0">
-              <a:buNone/>
-              <a:defRPr sz="2400" b="1"/>
-            </a:lvl1pPr>
-            <a:lvl2pPr marL="457200" indent="0">
-              <a:buNone/>
-              <a:defRPr sz="2000" b="1"/>
-            </a:lvl2pPr>
-            <a:lvl3pPr marL="914400" indent="0">
-              <a:buNone/>
-              <a:defRPr sz="1800" b="1"/>
-            </a:lvl3pPr>
-            <a:lvl4pPr marL="1371600" indent="0">
-              <a:buNone/>
-              <a:defRPr sz="1600" b="1"/>
-            </a:lvl4pPr>
-            <a:lvl5pPr marL="1828800" indent="0">
-              <a:buNone/>
-              <a:defRPr sz="1600" b="1"/>
-            </a:lvl5pPr>
-            <a:lvl6pPr marL="2286000" indent="0">
-              <a:buNone/>
-              <a:defRPr sz="1600" b="1"/>
-            </a:lvl6pPr>
-            <a:lvl7pPr marL="2743200" indent="0">
-              <a:buNone/>
-              <a:defRPr sz="1600" b="1"/>
-            </a:lvl7pPr>
-            <a:lvl8pPr marL="3200400" indent="0">
-              <a:buNone/>
-              <a:defRPr sz="1600" b="1"/>
-            </a:lvl8pPr>
-            <a:lvl9pPr marL="3657600" indent="0">
-              <a:buNone/>
-              <a:defRPr sz="1600" b="1"/>
-            </a:lvl9pPr>
-          </a:lstStyle>
-          <a:p>
-            <a:pPr lvl="0"/>
-            <a:r>
-              <a:rPr lang="en-US"/>
-              <a:t>Click to edit Master text styles</a:t>
-            </a:r>
-          </a:p>
-        </p:txBody>
-      </p:sp>
-      <p:sp>
-        <p:nvSpPr>
-          <p:cNvPr id="4" name="Content Placeholder 3"/>
-          <p:cNvSpPr>
-            <a:spLocks noGrp="1"/>
-          </p:cNvSpPr>
-          <p:nvPr>
-            <p:ph sz="half" idx="2"/>
-          </p:nvPr>
-        </p:nvSpPr>
-        <p:spPr>
-          <a:xfrm>
-            <a:off x="457200" y="2174875"/>
-            <a:ext cx="4040188" cy="3951288"/>
+            <a:off x="4594860" y="2507550"/>
+            <a:ext cx="3360420" cy="3664650"/>
           </a:xfrm>
         </p:spPr>
         <p:txBody>
           <a:bodyPr/>
           <a:lstStyle>
             <a:lvl1pPr>
-              <a:defRPr sz="2400"/>
+              <a:defRPr sz="1800"/>
             </a:lvl1pPr>
             <a:lvl2pPr>
-              <a:defRPr sz="2000"/>
+              <a:defRPr sz="1600"/>
             </a:lvl2pPr>
             <a:lvl3pPr>
-              <a:defRPr sz="1800"/>
+              <a:defRPr sz="1400"/>
             </a:lvl3pPr>
             <a:lvl4pPr>
-              <a:defRPr sz="1600"/>
+              <a:defRPr sz="1400"/>
             </a:lvl4pPr>
             <a:lvl5pPr>
-              <a:defRPr sz="1600"/>
+              <a:defRPr sz="1400"/>
             </a:lvl5pPr>
             <a:lvl6pPr>
-              <a:defRPr sz="1600"/>
+              <a:defRPr sz="1400"/>
             </a:lvl6pPr>
             <a:lvl7pPr>
-              <a:defRPr sz="1600"/>
+              <a:defRPr sz="1400"/>
             </a:lvl7pPr>
             <a:lvl8pPr>
-              <a:defRPr sz="1600"/>
+              <a:defRPr sz="1400"/>
             </a:lvl8pPr>
             <a:lvl9pPr>
-              <a:defRPr sz="1600"/>
+              <a:defRPr sz="1400"/>
             </a:lvl9pPr>
           </a:lstStyle>
           <a:p>
@@ -1648,155 +1903,7 @@
               <a:rPr lang="en-US"/>
               <a:t>Fifth level</a:t>
             </a:r>
-          </a:p>
-        </p:txBody>
-      </p:sp>
-      <p:sp>
-        <p:nvSpPr>
-          <p:cNvPr id="5" name="Text Placeholder 4"/>
-          <p:cNvSpPr>
-            <a:spLocks noGrp="1"/>
-          </p:cNvSpPr>
-          <p:nvPr>
-            <p:ph type="body" sz="quarter" idx="3"/>
-          </p:nvPr>
-        </p:nvSpPr>
-        <p:spPr>
-          <a:xfrm>
-            <a:off x="4645025" y="1535113"/>
-            <a:ext cx="4041775" cy="639762"/>
-          </a:xfrm>
-        </p:spPr>
-        <p:txBody>
-          <a:bodyPr anchor="b"/>
-          <a:lstStyle>
-            <a:lvl1pPr marL="0" indent="0">
-              <a:buNone/>
-              <a:defRPr sz="2400" b="1"/>
-            </a:lvl1pPr>
-            <a:lvl2pPr marL="457200" indent="0">
-              <a:buNone/>
-              <a:defRPr sz="2000" b="1"/>
-            </a:lvl2pPr>
-            <a:lvl3pPr marL="914400" indent="0">
-              <a:buNone/>
-              <a:defRPr sz="1800" b="1"/>
-            </a:lvl3pPr>
-            <a:lvl4pPr marL="1371600" indent="0">
-              <a:buNone/>
-              <a:defRPr sz="1600" b="1"/>
-            </a:lvl4pPr>
-            <a:lvl5pPr marL="1828800" indent="0">
-              <a:buNone/>
-              <a:defRPr sz="1600" b="1"/>
-            </a:lvl5pPr>
-            <a:lvl6pPr marL="2286000" indent="0">
-              <a:buNone/>
-              <a:defRPr sz="1600" b="1"/>
-            </a:lvl6pPr>
-            <a:lvl7pPr marL="2743200" indent="0">
-              <a:buNone/>
-              <a:defRPr sz="1600" b="1"/>
-            </a:lvl7pPr>
-            <a:lvl8pPr marL="3200400" indent="0">
-              <a:buNone/>
-              <a:defRPr sz="1600" b="1"/>
-            </a:lvl8pPr>
-            <a:lvl9pPr marL="3657600" indent="0">
-              <a:buNone/>
-              <a:defRPr sz="1600" b="1"/>
-            </a:lvl9pPr>
-          </a:lstStyle>
-          <a:p>
-            <a:pPr lvl="0"/>
-            <a:r>
-              <a:rPr lang="en-US"/>
-              <a:t>Click to edit Master text styles</a:t>
-            </a:r>
-          </a:p>
-        </p:txBody>
-      </p:sp>
-      <p:sp>
-        <p:nvSpPr>
-          <p:cNvPr id="6" name="Content Placeholder 5"/>
-          <p:cNvSpPr>
-            <a:spLocks noGrp="1"/>
-          </p:cNvSpPr>
-          <p:nvPr>
-            <p:ph sz="quarter" idx="4"/>
-          </p:nvPr>
-        </p:nvSpPr>
-        <p:spPr>
-          <a:xfrm>
-            <a:off x="4645025" y="2174875"/>
-            <a:ext cx="4041775" cy="3951288"/>
-          </a:xfrm>
-        </p:spPr>
-        <p:txBody>
-          <a:bodyPr/>
-          <a:lstStyle>
-            <a:lvl1pPr>
-              <a:defRPr sz="2400"/>
-            </a:lvl1pPr>
-            <a:lvl2pPr>
-              <a:defRPr sz="2000"/>
-            </a:lvl2pPr>
-            <a:lvl3pPr>
-              <a:defRPr sz="1800"/>
-            </a:lvl3pPr>
-            <a:lvl4pPr>
-              <a:defRPr sz="1600"/>
-            </a:lvl4pPr>
-            <a:lvl5pPr>
-              <a:defRPr sz="1600"/>
-            </a:lvl5pPr>
-            <a:lvl6pPr>
-              <a:defRPr sz="1600"/>
-            </a:lvl6pPr>
-            <a:lvl7pPr>
-              <a:defRPr sz="1600"/>
-            </a:lvl7pPr>
-            <a:lvl8pPr>
-              <a:defRPr sz="1600"/>
-            </a:lvl8pPr>
-            <a:lvl9pPr>
-              <a:defRPr sz="1600"/>
-            </a:lvl9pPr>
-          </a:lstStyle>
-          <a:p>
-            <a:pPr lvl="0"/>
-            <a:r>
-              <a:rPr lang="en-US"/>
-              <a:t>Click to edit Master text styles</a:t>
-            </a:r>
-          </a:p>
-          <a:p>
-            <a:pPr lvl="1"/>
-            <a:r>
-              <a:rPr lang="en-US"/>
-              <a:t>Second level</a:t>
-            </a:r>
-          </a:p>
-          <a:p>
-            <a:pPr lvl="2"/>
-            <a:r>
-              <a:rPr lang="en-US"/>
-              <a:t>Third level</a:t>
-            </a:r>
-          </a:p>
-          <a:p>
-            <a:pPr lvl="3"/>
-            <a:r>
-              <a:rPr lang="en-US"/>
-              <a:t>Fourth level</a:t>
-            </a:r>
-          </a:p>
-          <a:p>
-            <a:pPr lvl="4"/>
-            <a:r>
-              <a:rPr lang="en-US"/>
-              <a:t>Fifth level</a:t>
-            </a:r>
+            <a:endParaRPr lang="en-US" dirty="0"/>
           </a:p>
         </p:txBody>
       </p:sp>
@@ -1868,7 +1975,7 @@
     </p:spTree>
     <p:extLst>
       <p:ext uri="{BB962C8B-B14F-4D97-AF65-F5344CB8AC3E}">
-        <p14:creationId xmlns:p14="http://schemas.microsoft.com/office/powerpoint/2010/main" val="990158736"/>
+        <p14:creationId xmlns:p14="http://schemas.microsoft.com/office/powerpoint/2010/main" val="2455990127"/>
       </p:ext>
     </p:extLst>
   </p:cSld>
@@ -1897,7 +2004,7 @@
       </p:grpSpPr>
       <p:sp>
         <p:nvSpPr>
-          <p:cNvPr id="2" name="Title 1"/>
+          <p:cNvPr id="6" name="Title 5"/>
           <p:cNvSpPr>
             <a:spLocks noGrp="1"/>
           </p:cNvSpPr>
@@ -1914,6 +2021,7 @@
               <a:rPr lang="en-US"/>
               <a:t>Click to edit Master title style</a:t>
             </a:r>
+            <a:endParaRPr lang="en-US" dirty="0"/>
           </a:p>
         </p:txBody>
       </p:sp>
@@ -1985,7 +2093,7 @@
     </p:spTree>
     <p:extLst>
       <p:ext uri="{BB962C8B-B14F-4D97-AF65-F5344CB8AC3E}">
-        <p14:creationId xmlns:p14="http://schemas.microsoft.com/office/powerpoint/2010/main" val="727027711"/>
+        <p14:creationId xmlns:p14="http://schemas.microsoft.com/office/powerpoint/2010/main" val="3615706531"/>
       </p:ext>
     </p:extLst>
   </p:cSld>
@@ -2080,7 +2188,7 @@
     </p:spTree>
     <p:extLst>
       <p:ext uri="{BB962C8B-B14F-4D97-AF65-F5344CB8AC3E}">
-        <p14:creationId xmlns:p14="http://schemas.microsoft.com/office/powerpoint/2010/main" val="1212999818"/>
+        <p14:creationId xmlns:p14="http://schemas.microsoft.com/office/powerpoint/2010/main" val="2095125184"/>
       </p:ext>
     </p:extLst>
   </p:cSld>
@@ -2119,15 +2227,17 @@
         </p:nvSpPr>
         <p:spPr>
           <a:xfrm>
-            <a:off x="457200" y="273050"/>
-            <a:ext cx="3008313" cy="1162050"/>
+            <a:off x="630936" y="457201"/>
+            <a:ext cx="2400300" cy="1600197"/>
           </a:xfrm>
         </p:spPr>
         <p:txBody>
-          <a:bodyPr anchor="b"/>
+          <a:bodyPr anchor="b">
+            <a:normAutofit/>
+          </a:bodyPr>
           <a:lstStyle>
-            <a:lvl1pPr algn="l">
-              <a:defRPr sz="2000" b="1"/>
+            <a:lvl1pPr>
+              <a:defRPr sz="2800" b="0" baseline="0"/>
             </a:lvl1pPr>
           </a:lstStyle>
           <a:p>
@@ -2135,6 +2245,7 @@
               <a:rPr lang="en-US"/>
               <a:t>Click to edit Master title style</a:t>
             </a:r>
+            <a:endParaRPr lang="en-US" dirty="0"/>
           </a:p>
         </p:txBody>
       </p:sp>
@@ -2150,39 +2261,39 @@
         </p:nvSpPr>
         <p:spPr>
           <a:xfrm>
-            <a:off x="3575050" y="273050"/>
-            <a:ext cx="5111750" cy="5853113"/>
+            <a:off x="3378200" y="685800"/>
+            <a:ext cx="4559300" cy="5486400"/>
           </a:xfrm>
         </p:spPr>
         <p:txBody>
           <a:bodyPr/>
           <a:lstStyle>
             <a:lvl1pPr>
-              <a:defRPr sz="3200"/>
+              <a:defRPr sz="1800"/>
             </a:lvl1pPr>
             <a:lvl2pPr>
-              <a:defRPr sz="2800"/>
+              <a:defRPr sz="1600"/>
             </a:lvl2pPr>
             <a:lvl3pPr>
-              <a:defRPr sz="2400"/>
+              <a:defRPr sz="1400"/>
             </a:lvl3pPr>
             <a:lvl4pPr>
-              <a:defRPr sz="2000"/>
+              <a:defRPr sz="1400"/>
             </a:lvl4pPr>
             <a:lvl5pPr>
-              <a:defRPr sz="2000"/>
+              <a:defRPr sz="1400"/>
             </a:lvl5pPr>
             <a:lvl6pPr>
-              <a:defRPr sz="2000"/>
+              <a:defRPr sz="1400"/>
             </a:lvl6pPr>
             <a:lvl7pPr>
-              <a:defRPr sz="2000"/>
+              <a:defRPr sz="1400"/>
             </a:lvl7pPr>
             <a:lvl8pPr>
-              <a:defRPr sz="2000"/>
+              <a:defRPr sz="1400"/>
             </a:lvl8pPr>
             <a:lvl9pPr>
-              <a:defRPr sz="2000"/>
+              <a:defRPr sz="1400"/>
             </a:lvl9pPr>
           </a:lstStyle>
           <a:p>
@@ -2219,6 +2330,7 @@
               <a:rPr lang="en-US"/>
               <a:t>Fifth level</a:t>
             </a:r>
+            <a:endParaRPr lang="en-US" dirty="0"/>
           </a:p>
         </p:txBody>
       </p:sp>
@@ -2234,16 +2346,24 @@
         </p:nvSpPr>
         <p:spPr>
           <a:xfrm>
-            <a:off x="457200" y="1435100"/>
-            <a:ext cx="3008313" cy="4691063"/>
+            <a:off x="630936" y="2099735"/>
+            <a:ext cx="2400300" cy="3810001"/>
           </a:xfrm>
         </p:spPr>
         <p:txBody>
-          <a:bodyPr/>
+          <a:bodyPr>
+            <a:normAutofit/>
+          </a:bodyPr>
           <a:lstStyle>
             <a:lvl1pPr marL="0" indent="0">
-              <a:buNone/>
-              <a:defRPr sz="1400"/>
+              <a:lnSpc>
+                <a:spcPct val="114000"/>
+              </a:lnSpc>
+              <a:spcBef>
+                <a:spcPts val="800"/>
+              </a:spcBef>
+              <a:buNone/>
+              <a:defRPr sz="1300"/>
             </a:lvl1pPr>
             <a:lvl2pPr marL="457200" indent="0">
               <a:buNone/>
@@ -2355,7 +2475,7 @@
     </p:spTree>
     <p:extLst>
       <p:ext uri="{BB962C8B-B14F-4D97-AF65-F5344CB8AC3E}">
-        <p14:creationId xmlns:p14="http://schemas.microsoft.com/office/powerpoint/2010/main" val="1840726560"/>
+        <p14:creationId xmlns:p14="http://schemas.microsoft.com/office/powerpoint/2010/main" val="1828949811"/>
       </p:ext>
     </p:extLst>
   </p:cSld>
@@ -2384,25 +2504,69 @@
       </p:grpSpPr>
       <p:sp>
         <p:nvSpPr>
-          <p:cNvPr id="2" name="Title 1"/>
-          <p:cNvSpPr>
-            <a:spLocks noGrp="1"/>
-          </p:cNvSpPr>
-          <p:nvPr>
-            <p:ph type="title"/>
-          </p:nvPr>
+          <p:cNvPr id="8" name="Rectangle 7"/>
+          <p:cNvSpPr/>
+          <p:nvPr/>
         </p:nvSpPr>
         <p:spPr>
           <a:xfrm>
-            <a:off x="1792288" y="4800600"/>
-            <a:ext cx="5486400" cy="566738"/>
+            <a:off x="0" y="5105400"/>
+            <a:ext cx="8469630" cy="1752600"/>
+          </a:xfrm>
+          <a:prstGeom prst="rect">
+            <a:avLst/>
+          </a:prstGeom>
+          <a:solidFill>
+            <a:srgbClr val="000000"/>
+          </a:solidFill>
+          <a:ln>
+            <a:noFill/>
+          </a:ln>
+        </p:spPr>
+        <p:style>
+          <a:lnRef idx="2">
+            <a:schemeClr val="accent1">
+              <a:shade val="50000"/>
+            </a:schemeClr>
+          </a:lnRef>
+          <a:fillRef idx="1">
+            <a:schemeClr val="accent1"/>
+          </a:fillRef>
+          <a:effectRef idx="0">
+            <a:schemeClr val="accent1"/>
+          </a:effectRef>
+          <a:fontRef idx="minor">
+            <a:schemeClr val="lt1"/>
+          </a:fontRef>
+        </p:style>
+      </p:sp>
+      <p:sp>
+        <p:nvSpPr>
+          <p:cNvPr id="2" name="Title 1"/>
+          <p:cNvSpPr>
+            <a:spLocks noGrp="1"/>
+          </p:cNvSpPr>
+          <p:nvPr>
+            <p:ph type="title"/>
+          </p:nvPr>
+        </p:nvSpPr>
+        <p:spPr>
+          <a:xfrm>
+            <a:off x="685800" y="5257800"/>
+            <a:ext cx="7486650" cy="914400"/>
           </a:xfrm>
         </p:spPr>
         <p:txBody>
-          <a:bodyPr anchor="b"/>
+          <a:bodyPr anchor="b">
+            <a:normAutofit/>
+          </a:bodyPr>
           <a:lstStyle>
-            <a:lvl1pPr algn="l">
-              <a:defRPr sz="2000" b="1"/>
+            <a:lvl1pPr>
+              <a:defRPr sz="2800" b="0">
+                <a:solidFill>
+                  <a:schemeClr val="bg1"/>
+                </a:solidFill>
+              </a:defRPr>
             </a:lvl1pPr>
           </a:lstStyle>
           <a:p>
@@ -2410,6 +2574,7 @@
               <a:rPr lang="en-US"/>
               <a:t>Click to edit Master title style</a:t>
             </a:r>
+            <a:endParaRPr lang="en-US" dirty="0"/>
           </a:p>
         </p:txBody>
       </p:sp>
@@ -2417,7 +2582,7 @@
         <p:nvSpPr>
           <p:cNvPr id="3" name="Picture Placeholder 2"/>
           <p:cNvSpPr>
-            <a:spLocks noGrp="1"/>
+            <a:spLocks noGrp="1" noChangeAspect="1"/>
           </p:cNvSpPr>
           <p:nvPr>
             <p:ph type="pic" idx="1"/>
@@ -2425,16 +2590,23 @@
         </p:nvSpPr>
         <p:spPr>
           <a:xfrm>
-            <a:off x="1792288" y="612775"/>
-            <a:ext cx="5486400" cy="4114800"/>
+            <a:off x="0" y="1"/>
+            <a:ext cx="8469630" cy="5128923"/>
           </a:xfrm>
+          <a:solidFill>
+            <a:schemeClr val="accent1"/>
+          </a:solidFill>
         </p:spPr>
         <p:txBody>
-          <a:bodyPr/>
+          <a:bodyPr anchor="t"/>
           <a:lstStyle>
             <a:lvl1pPr marL="0" indent="0">
               <a:buNone/>
-              <a:defRPr sz="3200"/>
+              <a:defRPr sz="3200">
+                <a:solidFill>
+                  <a:schemeClr val="bg1"/>
+                </a:solidFill>
+              </a:defRPr>
             </a:lvl1pPr>
             <a:lvl2pPr marL="457200" indent="0">
               <a:buNone/>
@@ -2470,7 +2642,11 @@
             </a:lvl9pPr>
           </a:lstStyle>
           <a:p>
-            <a:endParaRPr lang="en-US"/>
+            <a:r>
+              <a:rPr lang="en-US"/>
+              <a:t>Click icon to add picture</a:t>
+            </a:r>
+            <a:endParaRPr lang="en-US" dirty="0"/>
           </a:p>
         </p:txBody>
       </p:sp>
@@ -2486,16 +2662,30 @@
         </p:nvSpPr>
         <p:spPr>
           <a:xfrm>
-            <a:off x="1792288" y="5367338"/>
-            <a:ext cx="5486400" cy="804862"/>
+            <a:off x="685800" y="6108590"/>
+            <a:ext cx="7486650" cy="597011"/>
           </a:xfrm>
         </p:spPr>
         <p:txBody>
-          <a:bodyPr/>
+          <a:bodyPr>
+            <a:normAutofit/>
+          </a:bodyPr>
           <a:lstStyle>
             <a:lvl1pPr marL="0" indent="0">
-              <a:buNone/>
-              <a:defRPr sz="1400"/>
+              <a:lnSpc>
+                <a:spcPct val="100000"/>
+              </a:lnSpc>
+              <a:spcBef>
+                <a:spcPts val="800"/>
+              </a:spcBef>
+              <a:buNone/>
+              <a:defRPr sz="1300">
+                <a:solidFill>
+                  <a:schemeClr val="bg1">
+                    <a:lumMod val="85000"/>
+                  </a:schemeClr>
+                </a:solidFill>
+              </a:defRPr>
             </a:lvl1pPr>
             <a:lvl2pPr marL="457200" indent="0">
               <a:buNone/>
@@ -2607,7 +2797,7 @@
     </p:spTree>
     <p:extLst>
       <p:ext uri="{BB962C8B-B14F-4D97-AF65-F5344CB8AC3E}">
-        <p14:creationId xmlns:p14="http://schemas.microsoft.com/office/powerpoint/2010/main" val="3889236939"/>
+        <p14:creationId xmlns:p14="http://schemas.microsoft.com/office/powerpoint/2010/main" val="2826394796"/>
       </p:ext>
     </p:extLst>
   </p:cSld>
@@ -2641,25 +2831,65 @@
       </p:grpSpPr>
       <p:sp>
         <p:nvSpPr>
-          <p:cNvPr id="2" name="Title Placeholder 1"/>
-          <p:cNvSpPr>
-            <a:spLocks noGrp="1"/>
-          </p:cNvSpPr>
-          <p:nvPr>
-            <p:ph type="title"/>
-          </p:nvPr>
+          <p:cNvPr id="7" name="Rectangle 6"/>
+          <p:cNvSpPr/>
+          <p:nvPr/>
         </p:nvSpPr>
         <p:spPr>
           <a:xfrm>
-            <a:off x="457200" y="274638"/>
-            <a:ext cx="8229600" cy="1143000"/>
+            <a:off x="8418195" y="0"/>
+            <a:ext cx="731520" cy="6858000"/>
+          </a:xfrm>
+          <a:prstGeom prst="rect">
+            <a:avLst/>
+          </a:prstGeom>
+          <a:solidFill>
+            <a:schemeClr val="tx2">
+              <a:lumMod val="75000"/>
+            </a:schemeClr>
+          </a:solidFill>
+          <a:ln>
+            <a:noFill/>
+          </a:ln>
+        </p:spPr>
+        <p:style>
+          <a:lnRef idx="2">
+            <a:schemeClr val="accent1">
+              <a:shade val="50000"/>
+            </a:schemeClr>
+          </a:lnRef>
+          <a:fillRef idx="1">
+            <a:schemeClr val="accent1"/>
+          </a:fillRef>
+          <a:effectRef idx="0">
+            <a:schemeClr val="accent1"/>
+          </a:effectRef>
+          <a:fontRef idx="minor">
+            <a:schemeClr val="lt1"/>
+          </a:fontRef>
+        </p:style>
+      </p:sp>
+      <p:sp>
+        <p:nvSpPr>
+          <p:cNvPr id="2" name="Title Placeholder 1"/>
+          <p:cNvSpPr>
+            <a:spLocks noGrp="1"/>
+          </p:cNvSpPr>
+          <p:nvPr>
+            <p:ph type="title"/>
+          </p:nvPr>
+        </p:nvSpPr>
+        <p:spPr>
+          <a:xfrm>
+            <a:off x="946404" y="365760"/>
+            <a:ext cx="7269480" cy="1325562"/>
           </a:xfrm>
           <a:prstGeom prst="rect">
             <a:avLst/>
           </a:prstGeom>
         </p:spPr>
         <p:txBody>
-          <a:bodyPr vert="horz" lIns="91440" tIns="45720" rIns="91440" bIns="45720" rtlCol="0" anchor="ctr">
+          <a:bodyPr vert="horz" lIns="91440" tIns="45720" rIns="91440" bIns="45720" rtlCol="0" anchor="b">
             <a:normAutofit/>
           </a:bodyPr>
           <a:lstStyle/>
@@ -2668,6 +2898,7 @@
               <a:rPr lang="en-US"/>
               <a:t>Click to edit Master title style</a:t>
             </a:r>
+            <a:endParaRPr lang="en-US" dirty="0"/>
           </a:p>
         </p:txBody>
       </p:sp>
@@ -2683,8 +2914,8 @@
         </p:nvSpPr>
         <p:spPr>
           <a:xfrm>
-            <a:off x="457200" y="1600200"/>
-            <a:ext cx="8229600" cy="4525963"/>
+            <a:off x="946404" y="1828801"/>
+            <a:ext cx="6446520" cy="4351337"/>
           </a:xfrm>
           <a:prstGeom prst="rect">
             <a:avLst/>
@@ -2729,6 +2960,7 @@
               <a:rPr lang="en-US"/>
               <a:t>Fifth level</a:t>
             </a:r>
+            <a:endParaRPr lang="en-US" dirty="0"/>
           </a:p>
         </p:txBody>
       </p:sp>
@@ -2743,9 +2975,9 @@
           </p:nvPr>
         </p:nvSpPr>
         <p:spPr>
-          <a:xfrm>
-            <a:off x="457200" y="6356350"/>
-            <a:ext cx="2133600" cy="365125"/>
+          <a:xfrm rot="16200000">
+            <a:off x="7831456" y="1044178"/>
+            <a:ext cx="1904999" cy="273844"/>
           </a:xfrm>
           <a:prstGeom prst="rect">
             <a:avLst/>
@@ -2754,11 +2986,12 @@
         <p:txBody>
           <a:bodyPr vert="horz" lIns="91440" tIns="45720" rIns="91440" bIns="45720" rtlCol="0" anchor="ctr"/>
           <a:lstStyle>
-            <a:lvl1pPr algn="l">
-              <a:defRPr sz="1200">
+            <a:lvl1pPr algn="r">
+              <a:defRPr sz="1050" b="0">
                 <a:solidFill>
-                  <a:schemeClr val="tx1">
-                    <a:tint val="75000"/>
+                  <a:schemeClr val="tx2">
+                    <a:lumMod val="20000"/>
+                    <a:lumOff val="80000"/>
                   </a:schemeClr>
                 </a:solidFill>
               </a:defRPr>
@@ -2784,9 +3017,9 @@
           </p:nvPr>
         </p:nvSpPr>
         <p:spPr>
-          <a:xfrm>
-            <a:off x="3124200" y="6356350"/>
-            <a:ext cx="2895600" cy="365125"/>
+          <a:xfrm rot="16200000">
+            <a:off x="6993255" y="4092178"/>
+            <a:ext cx="3581400" cy="273844"/>
           </a:xfrm>
           <a:prstGeom prst="rect">
             <a:avLst/>
@@ -2795,11 +3028,12 @@
         <p:txBody>
           <a:bodyPr vert="horz" lIns="91440" tIns="45720" rIns="91440" bIns="45720" rtlCol="0" anchor="ctr"/>
           <a:lstStyle>
-            <a:lvl1pPr algn="ctr">
-              <a:defRPr sz="1200">
+            <a:lvl1pPr algn="l">
+              <a:defRPr sz="1050">
                 <a:solidFill>
-                  <a:schemeClr val="tx1">
-                    <a:tint val="75000"/>
+                  <a:schemeClr val="tx2">
+                    <a:lumMod val="20000"/>
+                    <a:lumOff val="80000"/>
                   </a:schemeClr>
                 </a:solidFill>
               </a:defRPr>
@@ -2822,21 +3056,24 @@
         </p:nvSpPr>
         <p:spPr>
           <a:xfrm>
-            <a:off x="6553200" y="6356350"/>
-            <a:ext cx="2133600" cy="365125"/>
+            <a:off x="8441055" y="6172201"/>
+            <a:ext cx="685800" cy="593725"/>
           </a:xfrm>
           <a:prstGeom prst="rect">
             <a:avLst/>
           </a:prstGeom>
         </p:spPr>
         <p:txBody>
-          <a:bodyPr vert="horz" lIns="91440" tIns="45720" rIns="91440" bIns="45720" rtlCol="0" anchor="ctr"/>
+          <a:bodyPr vert="horz" lIns="27432" tIns="45720" rIns="27432" bIns="45720" rtlCol="0" anchor="ctr">
+            <a:normAutofit/>
+          </a:bodyPr>
           <a:lstStyle>
-            <a:lvl1pPr algn="r">
-              <a:defRPr sz="1200">
+            <a:lvl1pPr algn="ctr">
+              <a:defRPr sz="3200">
                 <a:solidFill>
-                  <a:schemeClr val="tx1">
-                    <a:tint val="75000"/>
+                  <a:schemeClr val="tx2">
+                    <a:lumMod val="60000"/>
+                    <a:lumOff val="40000"/>
                   </a:schemeClr>
                 </a:solidFill>
               </a:defRPr>
@@ -2854,32 +3091,35 @@
     </p:spTree>
     <p:extLst>
       <p:ext uri="{BB962C8B-B14F-4D97-AF65-F5344CB8AC3E}">
-        <p14:creationId xmlns:p14="http://schemas.microsoft.com/office/powerpoint/2010/main" val="2209977519"/>
+        <p14:creationId xmlns:p14="http://schemas.microsoft.com/office/powerpoint/2010/main" val="1413008509"/>
       </p:ext>
     </p:extLst>
   </p:cSld>
   <p:clrMap bg1="lt1" tx1="dk1" bg2="lt2" tx2="dk2" accent1="accent1" accent2="accent2" accent3="accent3" accent4="accent4" accent5="accent5" accent6="accent6" hlink="hlink" folHlink="folHlink"/>
   <p:sldLayoutIdLst>
-    <p:sldLayoutId id="2147483649" r:id="rId1"/>
-    <p:sldLayoutId id="2147483650" r:id="rId2"/>
-    <p:sldLayoutId id="2147483651" r:id="rId3"/>
-    <p:sldLayoutId id="2147483652" r:id="rId4"/>
-    <p:sldLayoutId id="2147483653" r:id="rId5"/>
-    <p:sldLayoutId id="2147483654" r:id="rId6"/>
-    <p:sldLayoutId id="2147483655" r:id="rId7"/>
-    <p:sldLayoutId id="2147483656" r:id="rId8"/>
-    <p:sldLayoutId id="2147483657" r:id="rId9"/>
-    <p:sldLayoutId id="2147483658" r:id="rId10"/>
-    <p:sldLayoutId id="2147483659" r:id="rId11"/>
+    <p:sldLayoutId id="2147483780" r:id="rId1"/>
+    <p:sldLayoutId id="2147483781" r:id="rId2"/>
+    <p:sldLayoutId id="2147483782" r:id="rId3"/>
+    <p:sldLayoutId id="2147483783" r:id="rId4"/>
+    <p:sldLayoutId id="2147483784" r:id="rId5"/>
+    <p:sldLayoutId id="2147483785" r:id="rId6"/>
+    <p:sldLayoutId id="2147483786" r:id="rId7"/>
+    <p:sldLayoutId id="2147483787" r:id="rId8"/>
+    <p:sldLayoutId id="2147483788" r:id="rId9"/>
+    <p:sldLayoutId id="2147483789" r:id="rId10"/>
+    <p:sldLayoutId id="2147483790" r:id="rId11"/>
   </p:sldLayoutIdLst>
   <p:txStyles>
     <p:titleStyle>
-      <a:lvl1pPr algn="ctr" defTabSz="457200" rtl="0" eaLnBrk="1" latinLnBrk="0" hangingPunct="1">
+      <a:lvl1pPr algn="l" defTabSz="914400" rtl="0" eaLnBrk="1" latinLnBrk="0" hangingPunct="1">
+        <a:lnSpc>
+          <a:spcPct val="90000"/>
+        </a:lnSpc>
         <a:spcBef>
           <a:spcPct val="0"/>
         </a:spcBef>
         <a:buNone/>
-        <a:defRPr sz="4400" kern="1200">
+        <a:defRPr sz="4000" kern="1200" spc="-50" baseline="0">
           <a:solidFill>
             <a:schemeClr val="tx1"/>
           </a:solidFill>
@@ -2890,13 +3130,23 @@
       </a:lvl1pPr>
     </p:titleStyle>
     <p:bodyStyle>
-      <a:lvl1pPr marL="342900" indent="-342900" algn="l" defTabSz="457200" rtl="0" eaLnBrk="1" latinLnBrk="0" hangingPunct="1">
+      <a:lvl1pPr marL="182880" indent="-182880" algn="l" defTabSz="914400" rtl="0" eaLnBrk="1" latinLnBrk="0" hangingPunct="1">
+        <a:lnSpc>
+          <a:spcPct val="95000"/>
+        </a:lnSpc>
         <a:spcBef>
-          <a:spcPct val="20000"/>
+          <a:spcPts val="1400"/>
         </a:spcBef>
-        <a:buFont typeface="Arial"/>
+        <a:spcAft>
+          <a:spcPts val="200"/>
+        </a:spcAft>
+        <a:buClr>
+          <a:schemeClr val="accent1"/>
+        </a:buClr>
+        <a:buSzPct val="80000"/>
+        <a:buFont typeface="Arial" pitchFamily="34" charset="0"/>
         <a:buChar char="•"/>
-        <a:defRPr sz="3200" kern="1200">
+        <a:defRPr sz="1800" kern="1200" spc="10" baseline="0">
           <a:solidFill>
             <a:schemeClr val="tx1"/>
           </a:solidFill>
@@ -2905,120 +3155,216 @@
           <a:cs typeface="+mn-cs"/>
         </a:defRPr>
       </a:lvl1pPr>
-      <a:lvl2pPr marL="742950" indent="-285750" algn="l" defTabSz="457200" rtl="0" eaLnBrk="1" latinLnBrk="0" hangingPunct="1">
+      <a:lvl2pPr marL="457200" indent="-182880" algn="l" defTabSz="914400" rtl="0" eaLnBrk="1" latinLnBrk="0" hangingPunct="1">
+        <a:lnSpc>
+          <a:spcPct val="90000"/>
+        </a:lnSpc>
         <a:spcBef>
-          <a:spcPct val="20000"/>
+          <a:spcPts val="300"/>
         </a:spcBef>
-        <a:buFont typeface="Arial"/>
-        <a:buChar char="–"/>
-        <a:defRPr sz="2800" kern="1200">
+        <a:spcAft>
+          <a:spcPts val="300"/>
+        </a:spcAft>
+        <a:buClr>
+          <a:schemeClr val="accent1"/>
+        </a:buClr>
+        <a:buFont typeface="Wingdings 2" pitchFamily="18" charset="2"/>
+        <a:buChar char=""/>
+        <a:defRPr sz="1600" kern="1200">
           <a:solidFill>
-            <a:schemeClr val="tx1"/>
+            <a:schemeClr val="tx1">
+              <a:lumMod val="85000"/>
+              <a:lumOff val="15000"/>
+            </a:schemeClr>
           </a:solidFill>
           <a:latin typeface="+mn-lt"/>
           <a:ea typeface="+mn-ea"/>
           <a:cs typeface="+mn-cs"/>
         </a:defRPr>
       </a:lvl2pPr>
-      <a:lvl3pPr marL="1143000" indent="-228600" algn="l" defTabSz="457200" rtl="0" eaLnBrk="1" latinLnBrk="0" hangingPunct="1">
+      <a:lvl3pPr marL="731520" indent="-182880" algn="l" defTabSz="914400" rtl="0" eaLnBrk="1" latinLnBrk="0" hangingPunct="1">
+        <a:lnSpc>
+          <a:spcPct val="90000"/>
+        </a:lnSpc>
         <a:spcBef>
-          <a:spcPct val="20000"/>
+          <a:spcPts val="300"/>
         </a:spcBef>
-        <a:buFont typeface="Arial"/>
-        <a:buChar char="•"/>
-        <a:defRPr sz="2400" kern="1200">
+        <a:spcAft>
+          <a:spcPts val="300"/>
+        </a:spcAft>
+        <a:buClr>
+          <a:schemeClr val="accent1"/>
+        </a:buClr>
+        <a:buFont typeface="Wingdings 2" pitchFamily="18" charset="2"/>
+        <a:buChar char=""/>
+        <a:defRPr sz="1400" kern="1200">
           <a:solidFill>
-            <a:schemeClr val="tx1"/>
+            <a:schemeClr val="tx1">
+              <a:lumMod val="85000"/>
+              <a:lumOff val="15000"/>
+            </a:schemeClr>
           </a:solidFill>
           <a:latin typeface="+mn-lt"/>
           <a:ea typeface="+mn-ea"/>
           <a:cs typeface="+mn-cs"/>
         </a:defRPr>
       </a:lvl3pPr>
-      <a:lvl4pPr marL="1600200" indent="-228600" algn="l" defTabSz="457200" rtl="0" eaLnBrk="1" latinLnBrk="0" hangingPunct="1">
+      <a:lvl4pPr marL="1005840" indent="-182880" algn="l" defTabSz="914400" rtl="0" eaLnBrk="1" latinLnBrk="0" hangingPunct="1">
+        <a:lnSpc>
+          <a:spcPct val="90000"/>
+        </a:lnSpc>
         <a:spcBef>
-          <a:spcPct val="20000"/>
+          <a:spcPts val="300"/>
         </a:spcBef>
-        <a:buFont typeface="Arial"/>
-        <a:buChar char="–"/>
-        <a:defRPr sz="2000" kern="1200">
+        <a:spcAft>
+          <a:spcPts val="300"/>
+        </a:spcAft>
+        <a:buClr>
+          <a:schemeClr val="accent1"/>
+        </a:buClr>
+        <a:buFont typeface="Wingdings 2" pitchFamily="18" charset="2"/>
+        <a:buChar char=""/>
+        <a:defRPr sz="1400" kern="1200">
           <a:solidFill>
-            <a:schemeClr val="tx1"/>
+            <a:schemeClr val="tx1">
+              <a:lumMod val="85000"/>
+              <a:lumOff val="15000"/>
+            </a:schemeClr>
           </a:solidFill>
           <a:latin typeface="+mn-lt"/>
           <a:ea typeface="+mn-ea"/>
           <a:cs typeface="+mn-cs"/>
         </a:defRPr>
       </a:lvl4pPr>
-      <a:lvl5pPr marL="2057400" indent="-228600" algn="l" defTabSz="457200" rtl="0" eaLnBrk="1" latinLnBrk="0" hangingPunct="1">
+      <a:lvl5pPr marL="1280160" indent="-182880" algn="l" defTabSz="914400" rtl="0" eaLnBrk="1" latinLnBrk="0" hangingPunct="1">
+        <a:lnSpc>
+          <a:spcPct val="90000"/>
+        </a:lnSpc>
         <a:spcBef>
-          <a:spcPct val="20000"/>
+          <a:spcPts val="300"/>
         </a:spcBef>
-        <a:buFont typeface="Arial"/>
-        <a:buChar char="»"/>
-        <a:defRPr sz="2000" kern="1200">
+        <a:spcAft>
+          <a:spcPts val="300"/>
+        </a:spcAft>
+        <a:buClr>
+          <a:schemeClr val="accent1"/>
+        </a:buClr>
+        <a:buFont typeface="Wingdings 2" pitchFamily="18" charset="2"/>
+        <a:buChar char=""/>
+        <a:defRPr sz="1400" kern="1200">
           <a:solidFill>
-            <a:schemeClr val="tx1"/>
+            <a:schemeClr val="tx1">
+              <a:lumMod val="85000"/>
+              <a:lumOff val="15000"/>
+            </a:schemeClr>
           </a:solidFill>
           <a:latin typeface="+mn-lt"/>
           <a:ea typeface="+mn-ea"/>
           <a:cs typeface="+mn-cs"/>
         </a:defRPr>
       </a:lvl5pPr>
-      <a:lvl6pPr marL="2514600" indent="-228600" algn="l" defTabSz="457200" rtl="0" eaLnBrk="1" latinLnBrk="0" hangingPunct="1">
+      <a:lvl6pPr marL="1600000" indent="-228600" algn="l" defTabSz="914400" rtl="0" eaLnBrk="1" latinLnBrk="0" hangingPunct="1">
+        <a:lnSpc>
+          <a:spcPct val="90000"/>
+        </a:lnSpc>
         <a:spcBef>
-          <a:spcPct val="20000"/>
+          <a:spcPts val="300"/>
         </a:spcBef>
-        <a:buFont typeface="Arial"/>
-        <a:buChar char="•"/>
-        <a:defRPr sz="2000" kern="1200">
+        <a:spcAft>
+          <a:spcPts val="300"/>
+        </a:spcAft>
+        <a:buClr>
+          <a:schemeClr val="accent1"/>
+        </a:buClr>
+        <a:buFont typeface="Wingdings 2" pitchFamily="18" charset="2"/>
+        <a:buChar char=""/>
+        <a:defRPr sz="1400" kern="1200">
           <a:solidFill>
-            <a:schemeClr val="tx1"/>
+            <a:schemeClr val="tx1">
+              <a:lumMod val="85000"/>
+              <a:lumOff val="15000"/>
+            </a:schemeClr>
           </a:solidFill>
           <a:latin typeface="+mn-lt"/>
           <a:ea typeface="+mn-ea"/>
           <a:cs typeface="+mn-cs"/>
         </a:defRPr>
       </a:lvl6pPr>
-      <a:lvl7pPr marL="2971800" indent="-228600" algn="l" defTabSz="457200" rtl="0" eaLnBrk="1" latinLnBrk="0" hangingPunct="1">
+      <a:lvl7pPr marL="1900000" indent="-228600" algn="l" defTabSz="914400" rtl="0" eaLnBrk="1" latinLnBrk="0" hangingPunct="1">
+        <a:lnSpc>
+          <a:spcPct val="90000"/>
+        </a:lnSpc>
         <a:spcBef>
-          <a:spcPct val="20000"/>
+          <a:spcPts val="300"/>
         </a:spcBef>
-        <a:buFont typeface="Arial"/>
-        <a:buChar char="•"/>
-        <a:defRPr sz="2000" kern="1200">
+        <a:spcAft>
+          <a:spcPts val="300"/>
+        </a:spcAft>
+        <a:buClr>
+          <a:schemeClr val="accent1"/>
+        </a:buClr>
+        <a:buFont typeface="Wingdings 2" pitchFamily="18" charset="2"/>
+        <a:buChar char=""/>
+        <a:defRPr sz="1400" kern="1200">
           <a:solidFill>
-            <a:schemeClr val="tx1"/>
+            <a:schemeClr val="tx1">
+              <a:lumMod val="85000"/>
+              <a:lumOff val="15000"/>
+            </a:schemeClr>
           </a:solidFill>
           <a:latin typeface="+mn-lt"/>
           <a:ea typeface="+mn-ea"/>
           <a:cs typeface="+mn-cs"/>
         </a:defRPr>
       </a:lvl7pPr>
-      <a:lvl8pPr marL="3429000" indent="-228600" algn="l" defTabSz="457200" rtl="0" eaLnBrk="1" latinLnBrk="0" hangingPunct="1">
+      <a:lvl8pPr marL="2200000" indent="-228600" algn="l" defTabSz="914400" rtl="0" eaLnBrk="1" latinLnBrk="0" hangingPunct="1">
+        <a:lnSpc>
+          <a:spcPct val="90000"/>
+        </a:lnSpc>
         <a:spcBef>
-          <a:spcPct val="20000"/>
+          <a:spcPts val="300"/>
         </a:spcBef>
-        <a:buFont typeface="Arial"/>
-        <a:buChar char="•"/>
-        <a:defRPr sz="2000" kern="1200">
+        <a:spcAft>
+          <a:spcPts val="300"/>
+        </a:spcAft>
+        <a:buClr>
+          <a:schemeClr val="accent1"/>
+        </a:buClr>
+        <a:buFont typeface="Wingdings 2" pitchFamily="18" charset="2"/>
+        <a:buChar char=""/>
+        <a:defRPr sz="1400" kern="1200">
           <a:solidFill>
-            <a:schemeClr val="tx1"/>
+            <a:schemeClr val="tx1">
+              <a:lumMod val="85000"/>
+              <a:lumOff val="15000"/>
+            </a:schemeClr>
           </a:solidFill>
           <a:latin typeface="+mn-lt"/>
           <a:ea typeface="+mn-ea"/>
           <a:cs typeface="+mn-cs"/>
         </a:defRPr>
       </a:lvl8pPr>
-      <a:lvl9pPr marL="3886200" indent="-228600" algn="l" defTabSz="457200" rtl="0" eaLnBrk="1" latinLnBrk="0" hangingPunct="1">
+      <a:lvl9pPr marL="2500000" indent="-228600" algn="l" defTabSz="914400" rtl="0" eaLnBrk="1" latinLnBrk="0" hangingPunct="1">
+        <a:lnSpc>
+          <a:spcPct val="90000"/>
+        </a:lnSpc>
         <a:spcBef>
-          <a:spcPct val="20000"/>
+          <a:spcPts val="300"/>
         </a:spcBef>
-        <a:buFont typeface="Arial"/>
-        <a:buChar char="•"/>
-        <a:defRPr sz="2000" kern="1200">
+        <a:spcAft>
+          <a:spcPts val="300"/>
+        </a:spcAft>
+        <a:buClr>
+          <a:schemeClr val="accent1"/>
+        </a:buClr>
+        <a:buFont typeface="Wingdings 2" pitchFamily="18" charset="2"/>
+        <a:buChar char=""/>
+        <a:defRPr sz="1400" kern="1200">
           <a:solidFill>
-            <a:schemeClr val="tx1"/>
+            <a:schemeClr val="tx1">
+              <a:lumMod val="85000"/>
+              <a:lumOff val="15000"/>
+            </a:schemeClr>
           </a:solidFill>
           <a:latin typeface="+mn-lt"/>
           <a:ea typeface="+mn-ea"/>
@@ -3030,7 +3376,7 @@
       <a:defPPr>
         <a:defRPr lang="en-US"/>
       </a:defPPr>
-      <a:lvl1pPr marL="0" algn="l" defTabSz="457200" rtl="0" eaLnBrk="1" latinLnBrk="0" hangingPunct="1">
+      <a:lvl1pPr marL="0" algn="l" defTabSz="914400" rtl="0" eaLnBrk="1" latinLnBrk="0" hangingPunct="1">
         <a:defRPr sz="1800" kern="1200">
           <a:solidFill>
             <a:schemeClr val="tx1"/>
@@ -3040,7 +3386,7 @@
           <a:cs typeface="+mn-cs"/>
         </a:defRPr>
       </a:lvl1pPr>
-      <a:lvl2pPr marL="457200" algn="l" defTabSz="457200" rtl="0" eaLnBrk="1" latinLnBrk="0" hangingPunct="1">
+      <a:lvl2pPr marL="457200" algn="l" defTabSz="914400" rtl="0" eaLnBrk="1" latinLnBrk="0" hangingPunct="1">
         <a:defRPr sz="1800" kern="1200">
           <a:solidFill>
             <a:schemeClr val="tx1"/>
@@ -3050,7 +3396,7 @@
           <a:cs typeface="+mn-cs"/>
         </a:defRPr>
       </a:lvl2pPr>
-      <a:lvl3pPr marL="914400" algn="l" defTabSz="457200" rtl="0" eaLnBrk="1" latinLnBrk="0" hangingPunct="1">
+      <a:lvl3pPr marL="914400" algn="l" defTabSz="914400" rtl="0" eaLnBrk="1" latinLnBrk="0" hangingPunct="1">
         <a:defRPr sz="1800" kern="1200">
           <a:solidFill>
             <a:schemeClr val="tx1"/>
@@ -3060,7 +3406,7 @@
           <a:cs typeface="+mn-cs"/>
         </a:defRPr>
       </a:lvl3pPr>
-      <a:lvl4pPr marL="1371600" algn="l" defTabSz="457200" rtl="0" eaLnBrk="1" latinLnBrk="0" hangingPunct="1">
+      <a:lvl4pPr marL="1371600" algn="l" defTabSz="914400" rtl="0" eaLnBrk="1" latinLnBrk="0" hangingPunct="1">
         <a:defRPr sz="1800" kern="1200">
           <a:solidFill>
             <a:schemeClr val="tx1"/>
@@ -3070,7 +3416,7 @@
           <a:cs typeface="+mn-cs"/>
         </a:defRPr>
       </a:lvl4pPr>
-      <a:lvl5pPr marL="1828800" algn="l" defTabSz="457200" rtl="0" eaLnBrk="1" latinLnBrk="0" hangingPunct="1">
+      <a:lvl5pPr marL="1828800" algn="l" defTabSz="914400" rtl="0" eaLnBrk="1" latinLnBrk="0" hangingPunct="1">
         <a:defRPr sz="1800" kern="1200">
           <a:solidFill>
             <a:schemeClr val="tx1"/>
@@ -3080,7 +3426,7 @@
           <a:cs typeface="+mn-cs"/>
         </a:defRPr>
       </a:lvl5pPr>
-      <a:lvl6pPr marL="2286000" algn="l" defTabSz="457200" rtl="0" eaLnBrk="1" latinLnBrk="0" hangingPunct="1">
+      <a:lvl6pPr marL="2286000" algn="l" defTabSz="914400" rtl="0" eaLnBrk="1" latinLnBrk="0" hangingPunct="1">
         <a:defRPr sz="1800" kern="1200">
           <a:solidFill>
             <a:schemeClr val="tx1"/>
@@ -3090,7 +3436,7 @@
           <a:cs typeface="+mn-cs"/>
         </a:defRPr>
       </a:lvl6pPr>
-      <a:lvl7pPr marL="2743200" algn="l" defTabSz="457200" rtl="0" eaLnBrk="1" latinLnBrk="0" hangingPunct="1">
+      <a:lvl7pPr marL="2743200" algn="l" defTabSz="914400" rtl="0" eaLnBrk="1" latinLnBrk="0" hangingPunct="1">
         <a:defRPr sz="1800" kern="1200">
           <a:solidFill>
             <a:schemeClr val="tx1"/>
@@ -3100,7 +3446,7 @@
           <a:cs typeface="+mn-cs"/>
         </a:defRPr>
       </a:lvl7pPr>
-      <a:lvl8pPr marL="3200400" algn="l" defTabSz="457200" rtl="0" eaLnBrk="1" latinLnBrk="0" hangingPunct="1">
+      <a:lvl8pPr marL="3200400" algn="l" defTabSz="914400" rtl="0" eaLnBrk="1" latinLnBrk="0" hangingPunct="1">
         <a:defRPr sz="1800" kern="1200">
           <a:solidFill>
             <a:schemeClr val="tx1"/>
@@ -3110,7 +3456,7 @@
           <a:cs typeface="+mn-cs"/>
         </a:defRPr>
       </a:lvl8pPr>
-      <a:lvl9pPr marL="3657600" algn="l" defTabSz="457200" rtl="0" eaLnBrk="1" latinLnBrk="0" hangingPunct="1">
+      <a:lvl9pPr marL="3657600" algn="l" defTabSz="914400" rtl="0" eaLnBrk="1" latinLnBrk="0" hangingPunct="1">
         <a:defRPr sz="1800" kern="1200">
           <a:solidFill>
             <a:schemeClr val="tx1"/>
@@ -3152,9 +3498,16 @@
             <p:ph type="ctrTitle"/>
           </p:nvPr>
         </p:nvSpPr>
-        <p:spPr/>
-        <p:txBody>
-          <a:bodyPr/>
+        <p:spPr>
+          <a:xfrm>
+            <a:off x="946404" y="685800"/>
+            <a:ext cx="7063740" cy="2743200"/>
+          </a:xfrm>
+        </p:spPr>
+        <p:txBody>
+          <a:bodyPr>
+            <a:normAutofit/>
+          </a:bodyPr>
           <a:lstStyle/>
           <a:p>
             <a:r>
@@ -3174,60 +3527,65 @@
             <p:ph type="subTitle" idx="1"/>
           </p:nvPr>
         </p:nvSpPr>
-        <p:spPr/>
+        <p:spPr>
+          <a:xfrm>
+            <a:off x="1040130" y="3447288"/>
+            <a:ext cx="7063740" cy="2523744"/>
+          </a:xfrm>
+        </p:spPr>
         <p:txBody>
           <a:bodyPr>
-            <a:normAutofit fontScale="47500" lnSpcReduction="20000"/>
+            <a:noAutofit/>
           </a:bodyPr>
           <a:lstStyle/>
           <a:p>
             <a:r>
-              <a:rPr dirty="0"/>
+              <a:rPr sz="1100" dirty="0"/>
               <a:t>IN501 Unit 9 Assignment</a:t>
             </a:r>
           </a:p>
           <a:p>
             <a:r>
-              <a:rPr dirty="0"/>
+              <a:rPr sz="1100" dirty="0"/>
               <a:t>Group Members: </a:t>
             </a:r>
-            <a:endParaRPr lang="en-US" dirty="0"/>
-          </a:p>
-          <a:p>
-            <a:r>
-              <a:rPr lang="en-US" dirty="0"/>
+            <a:endParaRPr lang="en-US" sz="1100" dirty="0"/>
+          </a:p>
+          <a:p>
+            <a:r>
+              <a:rPr lang="en-US" sz="1100" dirty="0"/>
               <a:t>Jamie Ridenour</a:t>
             </a:r>
           </a:p>
           <a:p>
             <a:r>
-              <a:rPr lang="en-US" dirty="0"/>
+              <a:rPr lang="en-US" sz="1100" dirty="0"/>
               <a:t>Robert Kresser</a:t>
             </a:r>
           </a:p>
           <a:p>
             <a:r>
-              <a:rPr lang="en-US" dirty="0"/>
+              <a:rPr lang="en-US" sz="1100" dirty="0"/>
               <a:t>Lane Meadows</a:t>
             </a:r>
           </a:p>
           <a:p>
             <a:r>
-              <a:rPr lang="en-US" dirty="0"/>
+              <a:rPr lang="en-US" sz="1100" dirty="0"/>
               <a:t>Francisca </a:t>
             </a:r>
             <a:r>
-              <a:rPr lang="en-US" dirty="0" err="1"/>
-              <a:t>Mpianin</a:t>
-            </a:r>
-            <a:endParaRPr lang="en-US" dirty="0"/>
-          </a:p>
-          <a:p>
-            <a:r>
-              <a:rPr lang="en-US" dirty="0"/>
+              <a:rPr lang="en-US" sz="1100" dirty="0" err="1"/>
+              <a:t>Mpianing</a:t>
+            </a:r>
+            <a:endParaRPr lang="en-US" sz="1100" dirty="0"/>
+          </a:p>
+          <a:p>
+            <a:r>
+              <a:rPr lang="en-US" sz="1100" dirty="0"/>
               <a:t>Marie Galarza</a:t>
             </a:r>
-            <a:endParaRPr dirty="0"/>
+            <a:endParaRPr sz="1100" dirty="0"/>
           </a:p>
         </p:txBody>
       </p:sp>
@@ -3266,12 +3624,18 @@
             <p:ph type="title"/>
           </p:nvPr>
         </p:nvSpPr>
-        <p:spPr/>
+        <p:spPr>
+          <a:xfrm>
+            <a:off x="937260" y="256032"/>
+            <a:ext cx="7269480" cy="667194"/>
+          </a:xfrm>
+        </p:spPr>
         <p:txBody>
           <a:bodyPr/>
           <a:lstStyle/>
           <a:p>
             <a:r>
+              <a:rPr dirty="0"/>
               <a:t>Baseline CNN Model</a:t>
             </a:r>
           </a:p>
@@ -3287,120 +3651,125 @@
             <p:ph idx="1"/>
           </p:nvPr>
         </p:nvSpPr>
-        <p:spPr/>
+        <p:spPr>
+          <a:xfrm>
+            <a:off x="946404" y="1014985"/>
+            <a:ext cx="6446520" cy="5705855"/>
+          </a:xfrm>
+        </p:spPr>
         <p:txBody>
           <a:bodyPr>
-            <a:normAutofit fontScale="55000" lnSpcReduction="20000"/>
+            <a:noAutofit/>
           </a:bodyPr>
           <a:lstStyle/>
           <a:p>
             <a:r>
-              <a:rPr dirty="0"/>
+              <a:rPr sz="1100" dirty="0"/>
               <a:t>Dataset: MNIST handwritten digit dataset</a:t>
             </a:r>
           </a:p>
           <a:p>
             <a:r>
-              <a:rPr dirty="0"/>
+              <a:rPr sz="1100" dirty="0"/>
               <a:t>Architecture: Sequential CNN</a:t>
             </a:r>
           </a:p>
           <a:p>
             <a:r>
-              <a:rPr dirty="0"/>
+              <a:rPr sz="1100" dirty="0"/>
               <a:t>- Conv2D (32 filters)</a:t>
             </a:r>
           </a:p>
           <a:p>
             <a:r>
-              <a:rPr dirty="0"/>
+              <a:rPr sz="1100" dirty="0"/>
               <a:t>- </a:t>
             </a:r>
             <a:r>
-              <a:rPr dirty="0" err="1"/>
+              <a:rPr sz="1100" dirty="0" err="1"/>
               <a:t>MaxPooling</a:t>
             </a:r>
-            <a:endParaRPr dirty="0"/>
-          </a:p>
-          <a:p>
-            <a:r>
-              <a:rPr dirty="0"/>
+            <a:endParaRPr sz="1100" dirty="0"/>
+          </a:p>
+          <a:p>
+            <a:r>
+              <a:rPr sz="1100" dirty="0"/>
               <a:t>- Conv2D (64 filters)</a:t>
             </a:r>
           </a:p>
           <a:p>
             <a:r>
-              <a:rPr dirty="0"/>
+              <a:rPr sz="1100" dirty="0"/>
               <a:t>- </a:t>
             </a:r>
             <a:r>
-              <a:rPr dirty="0" err="1"/>
+              <a:rPr sz="1100" dirty="0" err="1"/>
               <a:t>MaxPooling</a:t>
             </a:r>
-            <a:endParaRPr dirty="0"/>
-          </a:p>
-          <a:p>
-            <a:r>
-              <a:rPr dirty="0"/>
+            <a:endParaRPr sz="1100" dirty="0"/>
+          </a:p>
+          <a:p>
+            <a:r>
+              <a:rPr sz="1100" dirty="0"/>
               <a:t>- Flatten</a:t>
             </a:r>
           </a:p>
           <a:p>
             <a:r>
-              <a:rPr dirty="0"/>
+              <a:rPr sz="1100" dirty="0"/>
               <a:t>- Dense layers</a:t>
             </a:r>
           </a:p>
           <a:p>
-            <a:endParaRPr dirty="0"/>
-          </a:p>
-          <a:p>
-            <a:r>
-              <a:rPr dirty="0"/>
+            <a:endParaRPr sz="1100" dirty="0"/>
+          </a:p>
+          <a:p>
+            <a:r>
+              <a:rPr sz="1100" dirty="0"/>
               <a:t>Training Setup:</a:t>
             </a:r>
           </a:p>
           <a:p>
             <a:r>
-              <a:rPr dirty="0"/>
+              <a:rPr sz="1100" dirty="0"/>
               <a:t>- Optimizer: Adam</a:t>
             </a:r>
           </a:p>
           <a:p>
             <a:r>
-              <a:rPr dirty="0"/>
+              <a:rPr sz="1100" dirty="0"/>
               <a:t>- Epochs: 5</a:t>
             </a:r>
           </a:p>
           <a:p>
-            <a:endParaRPr dirty="0"/>
-          </a:p>
-          <a:p>
-            <a:r>
-              <a:rPr dirty="0"/>
+            <a:endParaRPr sz="1100" dirty="0"/>
+          </a:p>
+          <a:p>
+            <a:r>
+              <a:rPr sz="1100" dirty="0"/>
               <a:t>Results:</a:t>
             </a:r>
           </a:p>
           <a:p>
             <a:r>
-              <a:rPr dirty="0"/>
+              <a:rPr sz="1100" dirty="0"/>
               <a:t>Test Loss: </a:t>
             </a:r>
             <a:r>
-              <a:rPr lang="en-US" dirty="0"/>
+              <a:rPr lang="en-US" sz="1100" dirty="0"/>
               <a:t>0.0403</a:t>
             </a:r>
           </a:p>
           <a:p>
             <a:r>
-              <a:rPr dirty="0"/>
+              <a:rPr sz="1100" dirty="0"/>
               <a:t>Test Accuracy: </a:t>
             </a:r>
             <a:r>
-              <a:rPr lang="en-US" dirty="0"/>
+              <a:rPr lang="en-US" sz="1100" dirty="0"/>
               <a:t>0.9883</a:t>
             </a:r>
-            <a:endParaRPr dirty="0"/>
+            <a:endParaRPr sz="1100" dirty="0"/>
           </a:p>
         </p:txBody>
       </p:sp>
@@ -3460,10 +3829,15 @@
             <p:ph idx="1"/>
           </p:nvPr>
         </p:nvSpPr>
-        <p:spPr/>
+        <p:spPr>
+          <a:xfrm>
+            <a:off x="946404" y="2020825"/>
+            <a:ext cx="6446520" cy="4351337"/>
+          </a:xfrm>
+        </p:spPr>
         <p:txBody>
           <a:bodyPr>
-            <a:normAutofit fontScale="77500" lnSpcReduction="20000"/>
+            <a:normAutofit fontScale="92500" lnSpcReduction="10000"/>
           </a:bodyPr>
           <a:lstStyle/>
           <a:p>
@@ -3586,6 +3960,7 @@
           <a:lstStyle/>
           <a:p>
             <a:r>
+              <a:rPr dirty="0"/>
               <a:t>Variation 2 – Dropout Layer Added</a:t>
             </a:r>
           </a:p>
@@ -3601,10 +3976,15 @@
             <p:ph idx="1"/>
           </p:nvPr>
         </p:nvSpPr>
-        <p:spPr/>
+        <p:spPr>
+          <a:xfrm>
+            <a:off x="946404" y="2039113"/>
+            <a:ext cx="6446520" cy="4351337"/>
+          </a:xfrm>
+        </p:spPr>
         <p:txBody>
           <a:bodyPr>
-            <a:normAutofit fontScale="85000" lnSpcReduction="20000"/>
+            <a:normAutofit fontScale="92500" lnSpcReduction="10000"/>
           </a:bodyPr>
           <a:lstStyle/>
           <a:p>
@@ -3734,10 +4114,15 @@
             <p:ph idx="1"/>
           </p:nvPr>
         </p:nvSpPr>
-        <p:spPr/>
+        <p:spPr>
+          <a:xfrm>
+            <a:off x="946404" y="2011681"/>
+            <a:ext cx="6446520" cy="4351337"/>
+          </a:xfrm>
+        </p:spPr>
         <p:txBody>
           <a:bodyPr>
-            <a:normAutofit fontScale="85000" lnSpcReduction="20000"/>
+            <a:normAutofit fontScale="92500" lnSpcReduction="10000"/>
           </a:bodyPr>
           <a:lstStyle/>
           <a:p>
@@ -3751,7 +4136,7 @@
             </a:r>
             <a:r>
               <a:rPr lang="en-US" dirty="0" err="1"/>
-              <a:t>Mpianin</a:t>
+              <a:t>Mpianing</a:t>
             </a:r>
             <a:endParaRPr lang="en-US" dirty="0"/>
           </a:p>
@@ -3877,10 +4262,15 @@
             <p:ph idx="1"/>
           </p:nvPr>
         </p:nvSpPr>
-        <p:spPr/>
+        <p:spPr>
+          <a:xfrm>
+            <a:off x="946404" y="2011681"/>
+            <a:ext cx="6446520" cy="4351337"/>
+          </a:xfrm>
+        </p:spPr>
         <p:txBody>
           <a:bodyPr>
-            <a:normAutofit fontScale="85000" lnSpcReduction="20000"/>
+            <a:normAutofit lnSpcReduction="10000"/>
           </a:bodyPr>
           <a:lstStyle/>
           <a:p>
@@ -3991,7 +4381,7 @@
         <p:spPr/>
         <p:txBody>
           <a:bodyPr>
-            <a:normAutofit fontScale="90000"/>
+            <a:normAutofit/>
           </a:bodyPr>
           <a:lstStyle/>
           <a:p>
@@ -4011,10 +4401,15 @@
             <p:ph idx="1"/>
           </p:nvPr>
         </p:nvSpPr>
-        <p:spPr/>
+        <p:spPr>
+          <a:xfrm>
+            <a:off x="946404" y="1993393"/>
+            <a:ext cx="6446520" cy="4351337"/>
+          </a:xfrm>
+        </p:spPr>
         <p:txBody>
           <a:bodyPr>
-            <a:normAutofit fontScale="92500" lnSpcReduction="20000"/>
+            <a:normAutofit/>
           </a:bodyPr>
           <a:lstStyle/>
           <a:p>
@@ -4082,12 +4477,8 @@
               <a:t>Observation: </a:t>
             </a:r>
             <a:r>
-              <a:rPr lang="en-US"/>
-              <a:t>Decrease accuracy of </a:t>
-            </a:r>
-            <a:r>
               <a:rPr lang="en-US" dirty="0"/>
-              <a:t>0.0012</a:t>
+              <a:t>Decrease accuracy of 0.0012</a:t>
             </a:r>
             <a:endParaRPr dirty="0"/>
           </a:p>
@@ -4104,6 +4495,14 @@
 <file path=ppt/slides/slide8.xml><?xml version="1.0" encoding="utf-8"?>
 <p:sld xmlns:a="http://schemas.openxmlformats.org/drawingml/2006/main" xmlns:r="http://schemas.openxmlformats.org/officeDocument/2006/relationships" xmlns:p="http://schemas.openxmlformats.org/presentationml/2006/main">
   <p:cSld>
+    <p:bg>
+      <p:bgPr>
+        <a:solidFill>
+          <a:schemeClr val="bg1"/>
+        </a:solidFill>
+        <a:effectLst/>
+      </p:bgPr>
+    </p:bg>
     <p:spTree>
       <p:nvGrpSpPr>
         <p:cNvPr id="1" name=""/>
@@ -4120,6 +4519,132 @@
       </p:grpSpPr>
       <p:sp>
         <p:nvSpPr>
+          <p:cNvPr id="8" name="Rectangle 7">
+            <a:extLst>
+              <a:ext uri="{FF2B5EF4-FFF2-40B4-BE49-F238E27FC236}">
+                <a16:creationId xmlns:a16="http://schemas.microsoft.com/office/drawing/2014/main" id="{33801627-6861-4EA9-BE98-E0CE33A894D9}"/>
+              </a:ext>
+              <a:ext uri="{C183D7F6-B498-43B3-948B-1728B52AA6E4}">
+                <adec:decorative xmlns:adec="http://schemas.microsoft.com/office/drawing/2017/decorative" val="1"/>
+              </a:ext>
+            </a:extLst>
+          </p:cNvPr>
+          <p:cNvSpPr>
+            <a:spLocks noGrp="1" noRot="1" noChangeAspect="1" noMove="1" noResize="1" noEditPoints="1" noAdjustHandles="1" noChangeArrowheads="1" noChangeShapeType="1" noTextEdit="1"/>
+          </p:cNvSpPr>
+          <p:nvPr>
+            <p:extLst>
+              <p:ext uri="{386F3935-93C4-4BCD-93E2-E3B085C9AB24}">
+                <p16:designElem xmlns:p16="http://schemas.microsoft.com/office/powerpoint/2015/main" val="1"/>
+              </p:ext>
+            </p:extLst>
+          </p:nvPr>
+        </p:nvSpPr>
+        <p:spPr>
+          <a:xfrm>
+            <a:off x="0" y="0"/>
+            <a:ext cx="482600" cy="6858000"/>
+          </a:xfrm>
+          <a:prstGeom prst="rect">
+            <a:avLst/>
+          </a:prstGeom>
+          <a:solidFill>
+            <a:srgbClr val="0D0D0D"/>
+          </a:solidFill>
+          <a:ln>
+            <a:noFill/>
+          </a:ln>
+        </p:spPr>
+        <p:style>
+          <a:lnRef idx="2">
+            <a:schemeClr val="accent1">
+              <a:shade val="50000"/>
+            </a:schemeClr>
+          </a:lnRef>
+          <a:fillRef idx="1">
+            <a:schemeClr val="accent1"/>
+          </a:fillRef>
+          <a:effectRef idx="0">
+            <a:schemeClr val="accent1"/>
+          </a:effectRef>
+          <a:fontRef idx="minor">
+            <a:schemeClr val="lt1"/>
+          </a:fontRef>
+        </p:style>
+        <p:txBody>
+          <a:bodyPr rtlCol="0" anchor="ctr"/>
+          <a:lstStyle/>
+          <a:p>
+            <a:pPr algn="ctr"/>
+            <a:endParaRPr lang="en-US"/>
+          </a:p>
+        </p:txBody>
+      </p:sp>
+      <p:sp>
+        <p:nvSpPr>
+          <p:cNvPr id="10" name="Rectangle 9">
+            <a:extLst>
+              <a:ext uri="{FF2B5EF4-FFF2-40B4-BE49-F238E27FC236}">
+                <a16:creationId xmlns:a16="http://schemas.microsoft.com/office/drawing/2014/main" id="{93C1483F-490E-4C8A-8765-1F8AF0C67D5F}"/>
+              </a:ext>
+              <a:ext uri="{C183D7F6-B498-43B3-948B-1728B52AA6E4}">
+                <adec:decorative xmlns:adec="http://schemas.microsoft.com/office/drawing/2017/decorative" val="1"/>
+              </a:ext>
+            </a:extLst>
+          </p:cNvPr>
+          <p:cNvSpPr>
+            <a:spLocks noGrp="1" noRot="1" noChangeAspect="1" noMove="1" noResize="1" noEditPoints="1" noAdjustHandles="1" noChangeArrowheads="1" noChangeShapeType="1" noTextEdit="1"/>
+          </p:cNvSpPr>
+          <p:nvPr>
+            <p:extLst>
+              <p:ext uri="{386F3935-93C4-4BCD-93E2-E3B085C9AB24}">
+                <p16:designElem xmlns:p16="http://schemas.microsoft.com/office/powerpoint/2015/main" val="1"/>
+              </p:ext>
+            </p:extLst>
+          </p:nvPr>
+        </p:nvSpPr>
+        <p:spPr>
+          <a:xfrm>
+            <a:off x="482599" y="0"/>
+            <a:ext cx="2802142" cy="6858000"/>
+          </a:xfrm>
+          <a:prstGeom prst="rect">
+            <a:avLst/>
+          </a:prstGeom>
+          <a:solidFill>
+            <a:srgbClr val="292929"/>
+          </a:solidFill>
+          <a:ln>
+            <a:noFill/>
+          </a:ln>
+        </p:spPr>
+        <p:style>
+          <a:lnRef idx="2">
+            <a:schemeClr val="accent1">
+              <a:shade val="50000"/>
+            </a:schemeClr>
+          </a:lnRef>
+          <a:fillRef idx="1">
+            <a:schemeClr val="accent1"/>
+          </a:fillRef>
+          <a:effectRef idx="0">
+            <a:schemeClr val="accent1"/>
+          </a:effectRef>
+          <a:fontRef idx="minor">
+            <a:schemeClr val="lt1"/>
+          </a:fontRef>
+        </p:style>
+        <p:txBody>
+          <a:bodyPr rtlCol="0" anchor="ctr"/>
+          <a:lstStyle/>
+          <a:p>
+            <a:pPr algn="ctr"/>
+            <a:endParaRPr lang="en-US"/>
+          </a:p>
+        </p:txBody>
+      </p:sp>
+      <p:sp>
+        <p:nvSpPr>
           <p:cNvPr id="2" name="Title 1"/>
           <p:cNvSpPr>
             <a:spLocks noGrp="1"/>
@@ -4128,57 +4653,129 @@
             <p:ph type="title"/>
           </p:nvPr>
         </p:nvSpPr>
-        <p:spPr/>
+        <p:spPr>
+          <a:xfrm>
+            <a:off x="723898" y="643466"/>
+            <a:ext cx="2319539" cy="5528734"/>
+          </a:xfrm>
+          <a:noFill/>
+        </p:spPr>
+        <p:txBody>
+          <a:bodyPr anchor="t">
+            <a:normAutofit/>
+          </a:bodyPr>
+          <a:lstStyle/>
+          <a:p>
+            <a:r>
+              <a:rPr lang="en-US" sz="2400">
+                <a:solidFill>
+                  <a:srgbClr val="FFFFFF"/>
+                </a:solidFill>
+              </a:rPr>
+              <a:t>Final Model Comparison and Key Findings</a:t>
+            </a:r>
+          </a:p>
+        </p:txBody>
+      </p:sp>
+      <p:sp useBgFill="1">
+        <p:nvSpPr>
+          <p:cNvPr id="12" name="Rectangle 11">
+            <a:extLst>
+              <a:ext uri="{FF2B5EF4-FFF2-40B4-BE49-F238E27FC236}">
+                <a16:creationId xmlns:a16="http://schemas.microsoft.com/office/drawing/2014/main" id="{0249BF42-D05C-4553-9417-7B8695759291}"/>
+              </a:ext>
+              <a:ext uri="{C183D7F6-B498-43B3-948B-1728B52AA6E4}">
+                <adec:decorative xmlns:adec="http://schemas.microsoft.com/office/drawing/2017/decorative" val="1"/>
+              </a:ext>
+            </a:extLst>
+          </p:cNvPr>
+          <p:cNvSpPr>
+            <a:spLocks noGrp="1" noRot="1" noChangeAspect="1" noMove="1" noResize="1" noEditPoints="1" noAdjustHandles="1" noChangeArrowheads="1" noChangeShapeType="1" noTextEdit="1"/>
+          </p:cNvSpPr>
+          <p:nvPr>
+            <p:extLst>
+              <p:ext uri="{386F3935-93C4-4BCD-93E2-E3B085C9AB24}">
+                <p16:designElem xmlns:p16="http://schemas.microsoft.com/office/powerpoint/2015/main" val="1"/>
+              </p:ext>
+            </p:extLst>
+          </p:nvPr>
+        </p:nvSpPr>
+        <p:spPr>
+          <a:xfrm>
+            <a:off x="3284740" y="0"/>
+            <a:ext cx="5184889" cy="6858000"/>
+          </a:xfrm>
+          <a:prstGeom prst="rect">
+            <a:avLst/>
+          </a:prstGeom>
+          <a:ln>
+            <a:noFill/>
+          </a:ln>
+        </p:spPr>
+        <p:style>
+          <a:lnRef idx="2">
+            <a:schemeClr val="accent1">
+              <a:shade val="50000"/>
+            </a:schemeClr>
+          </a:lnRef>
+          <a:fillRef idx="1">
+            <a:schemeClr val="accent1"/>
+          </a:fillRef>
+          <a:effectRef idx="0">
+            <a:schemeClr val="accent1"/>
+          </a:effectRef>
+          <a:fontRef idx="minor">
+            <a:schemeClr val="lt1"/>
+          </a:fontRef>
+        </p:style>
+        <p:txBody>
+          <a:bodyPr rtlCol="0" anchor="ctr"/>
+          <a:lstStyle/>
+          <a:p>
+            <a:pPr algn="ctr"/>
+            <a:endParaRPr lang="en-US"/>
+          </a:p>
+        </p:txBody>
+      </p:sp>
+      <p:sp>
+        <p:nvSpPr>
+          <p:cNvPr id="3" name="Content Placeholder 2"/>
+          <p:cNvSpPr>
+            <a:spLocks noGrp="1"/>
+          </p:cNvSpPr>
+          <p:nvPr>
+            <p:ph idx="1"/>
+          </p:nvPr>
+        </p:nvSpPr>
+        <p:spPr>
+          <a:xfrm>
+            <a:off x="3616423" y="256032"/>
+            <a:ext cx="4370604" cy="6355080"/>
+          </a:xfrm>
+        </p:spPr>
         <p:txBody>
           <a:bodyPr>
-            <a:normAutofit fontScale="90000"/>
+            <a:normAutofit/>
           </a:bodyPr>
           <a:lstStyle/>
           <a:p>
             <a:r>
-              <a:t>Final Model Comparison and Key Findings</a:t>
-            </a:r>
-          </a:p>
-        </p:txBody>
-      </p:sp>
-      <p:sp>
-        <p:nvSpPr>
-          <p:cNvPr id="3" name="Content Placeholder 2"/>
-          <p:cNvSpPr>
-            <a:spLocks noGrp="1"/>
-          </p:cNvSpPr>
-          <p:nvPr>
-            <p:ph idx="1"/>
-          </p:nvPr>
-        </p:nvSpPr>
-        <p:spPr/>
-        <p:txBody>
-          <a:bodyPr>
-            <a:normAutofit fontScale="47500" lnSpcReduction="20000"/>
-          </a:bodyPr>
-          <a:lstStyle/>
-          <a:p>
-            <a:r>
-              <a:rPr dirty="0"/>
+              <a:rPr lang="en-US" sz="1100" dirty="0"/>
               <a:t>Model Comparison:</a:t>
             </a:r>
           </a:p>
           <a:p>
             <a:r>
-              <a:rPr dirty="0"/>
-              <a:t>Baseline Model –</a:t>
-            </a:r>
-            <a:r>
-              <a:rPr lang="en-US" dirty="0"/>
-              <a:t> 0.9883</a:t>
-            </a:r>
-          </a:p>
-          <a:p>
-            <a:r>
-              <a:rPr lang="en-US" dirty="0"/>
+              <a:rPr lang="en-US" sz="1100" dirty="0"/>
+              <a:t>Baseline Model – 0.9883</a:t>
+            </a:r>
+          </a:p>
+          <a:p>
+            <a:r>
+              <a:rPr lang="en-US" sz="1100" dirty="0"/>
               <a:t>Variation 1 – Increased Filters: 0.9907</a:t>
             </a:r>
-            <a:endParaRPr lang="en-US" dirty="0">
+            <a:endParaRPr lang="en-US" sz="1100" dirty="0">
               <a:highlight>
                 <a:srgbClr val="FFFF00"/>
               </a:highlight>
@@ -4186,21 +4783,17 @@
           </a:p>
           <a:p>
             <a:r>
-              <a:rPr dirty="0"/>
-              <a:t>Variation 2 – Dropout: </a:t>
-            </a:r>
-            <a:r>
-              <a:rPr lang="en-US" dirty="0"/>
-              <a:t>0.9924</a:t>
-            </a:r>
-          </a:p>
-          <a:p>
-            <a:r>
-              <a:rPr lang="en-US" dirty="0"/>
+              <a:rPr lang="en-US" sz="1100" dirty="0"/>
+              <a:t>Variation 2 – Dropout: 0.9924</a:t>
+            </a:r>
+          </a:p>
+          <a:p>
+            <a:r>
+              <a:rPr lang="en-US" sz="1100" dirty="0"/>
               <a:t>Variation 3 – More Epochs: </a:t>
             </a:r>
             <a:r>
-              <a:rPr lang="en-US" dirty="0">
+              <a:rPr lang="en-US" sz="1100" dirty="0">
                 <a:highlight>
                   <a:srgbClr val="FFFF00"/>
                 </a:highlight>
@@ -4210,11 +4803,11 @@
           </a:p>
           <a:p>
             <a:r>
-              <a:rPr dirty="0"/>
+              <a:rPr lang="en-US" sz="1100" dirty="0"/>
               <a:t>Variation 4 – SGD Optimizer: </a:t>
             </a:r>
             <a:r>
-              <a:rPr dirty="0">
+              <a:rPr lang="en-US" sz="1100" dirty="0">
                 <a:highlight>
                   <a:srgbClr val="FFFF00"/>
                 </a:highlight>
@@ -4224,60 +4817,55 @@
           </a:p>
           <a:p>
             <a:r>
-              <a:rPr dirty="0"/>
-              <a:t>Variation 5 – Extra Conv Layer: </a:t>
-            </a:r>
-            <a:r>
-              <a:rPr lang="en-US" dirty="0"/>
-              <a:t>0.9871</a:t>
-            </a:r>
-            <a:endParaRPr dirty="0"/>
-          </a:p>
-          <a:p>
-            <a:endParaRPr dirty="0"/>
-          </a:p>
-          <a:p>
-            <a:r>
-              <a:rPr dirty="0"/>
+              <a:rPr lang="en-US" sz="1100" dirty="0"/>
+              <a:t>Variation 5 – Extra Conv Layer: 0.9871</a:t>
+            </a:r>
+          </a:p>
+          <a:p>
+            <a:endParaRPr lang="en-US" sz="1100" dirty="0"/>
+          </a:p>
+          <a:p>
+            <a:r>
+              <a:rPr lang="en-US" sz="1100" dirty="0"/>
               <a:t>Key Findings:</a:t>
             </a:r>
           </a:p>
           <a:p>
             <a:r>
-              <a:rPr dirty="0"/>
+              <a:rPr lang="en-US" sz="1100" dirty="0"/>
               <a:t>- Increasing model complexity improved feature detection.</a:t>
             </a:r>
           </a:p>
           <a:p>
             <a:r>
-              <a:rPr dirty="0"/>
+              <a:rPr lang="en-US" sz="1100" dirty="0"/>
               <a:t>- Dropout helped reduce overfitting.</a:t>
             </a:r>
           </a:p>
           <a:p>
             <a:r>
-              <a:rPr dirty="0"/>
+              <a:rPr lang="en-US" sz="1100" dirty="0"/>
               <a:t>- Additional epochs improved learning but increased training time.</a:t>
             </a:r>
           </a:p>
           <a:p>
             <a:r>
-              <a:rPr dirty="0"/>
+              <a:rPr lang="en-US" sz="1100" dirty="0"/>
               <a:t>- Different optimizers affected training speed and stability.</a:t>
             </a:r>
           </a:p>
           <a:p>
-            <a:endParaRPr dirty="0"/>
-          </a:p>
-          <a:p>
-            <a:r>
-              <a:rPr dirty="0"/>
+            <a:endParaRPr lang="en-US" sz="1100" dirty="0"/>
+          </a:p>
+          <a:p>
+            <a:r>
+              <a:rPr lang="en-US" sz="1100" dirty="0"/>
               <a:t>Conclusion:</a:t>
             </a:r>
           </a:p>
           <a:p>
             <a:r>
-              <a:rPr dirty="0"/>
+              <a:rPr lang="en-US" sz="1100" dirty="0"/>
               <a:t>CNN performance is highly dependent on parameter tuning. Balancing model complexity, accuracy, and training time is essential.</a:t>
             </a:r>
           </a:p>
@@ -4294,6 +4882,17 @@
 <file path=ppt/slides/slide9.xml><?xml version="1.0" encoding="utf-8"?>
 <p:sld xmlns:a="http://schemas.openxmlformats.org/drawingml/2006/main" xmlns:r="http://schemas.openxmlformats.org/officeDocument/2006/relationships" xmlns:p="http://schemas.openxmlformats.org/presentationml/2006/main">
   <p:cSld>
+    <p:bg>
+      <p:bgPr>
+        <a:solidFill>
+          <a:schemeClr val="bg1">
+            <a:tint val="95000"/>
+            <a:satMod val="170000"/>
+          </a:schemeClr>
+        </a:solidFill>
+        <a:effectLst/>
+      </p:bgPr>
+    </p:bg>
     <p:spTree>
       <p:nvGrpSpPr>
         <p:cNvPr id="1" name=""/>
@@ -4308,6 +4907,66 @@
           <a:chExt cx="0" cy="0"/>
         </a:xfrm>
       </p:grpSpPr>
+      <p:sp useBgFill="1">
+        <p:nvSpPr>
+          <p:cNvPr id="8" name="Rectangle 7">
+            <a:extLst>
+              <a:ext uri="{FF2B5EF4-FFF2-40B4-BE49-F238E27FC236}">
+                <a16:creationId xmlns:a16="http://schemas.microsoft.com/office/drawing/2014/main" id="{5DB0431E-0B04-44A1-9C51-531E28D18A60}"/>
+              </a:ext>
+              <a:ext uri="{C183D7F6-B498-43B3-948B-1728B52AA6E4}">
+                <adec:decorative xmlns:adec="http://schemas.microsoft.com/office/drawing/2017/decorative" val="1"/>
+              </a:ext>
+            </a:extLst>
+          </p:cNvPr>
+          <p:cNvSpPr>
+            <a:spLocks noGrp="1" noRot="1" noChangeAspect="1" noMove="1" noResize="1" noEditPoints="1" noAdjustHandles="1" noChangeArrowheads="1" noChangeShapeType="1" noTextEdit="1"/>
+          </p:cNvSpPr>
+          <p:nvPr>
+            <p:extLst>
+              <p:ext uri="{386F3935-93C4-4BCD-93E2-E3B085C9AB24}">
+                <p16:designElem xmlns:p16="http://schemas.microsoft.com/office/powerpoint/2015/main" val="1"/>
+              </p:ext>
+            </p:extLst>
+          </p:nvPr>
+        </p:nvSpPr>
+        <p:spPr>
+          <a:xfrm>
+            <a:off x="0" y="0"/>
+            <a:ext cx="9144000" cy="6858000"/>
+          </a:xfrm>
+          <a:prstGeom prst="rect">
+            <a:avLst/>
+          </a:prstGeom>
+          <a:ln>
+            <a:noFill/>
+          </a:ln>
+        </p:spPr>
+        <p:style>
+          <a:lnRef idx="2">
+            <a:schemeClr val="accent1">
+              <a:shade val="50000"/>
+            </a:schemeClr>
+          </a:lnRef>
+          <a:fillRef idx="1">
+            <a:schemeClr val="accent1"/>
+          </a:fillRef>
+          <a:effectRef idx="0">
+            <a:schemeClr val="accent1"/>
+          </a:effectRef>
+          <a:fontRef idx="minor">
+            <a:schemeClr val="lt1"/>
+          </a:fontRef>
+        </p:style>
+        <p:txBody>
+          <a:bodyPr rtlCol="0" anchor="ctr"/>
+          <a:lstStyle/>
+          <a:p>
+            <a:pPr algn="ctr"/>
+            <a:endParaRPr lang="en-US"/>
+          </a:p>
+        </p:txBody>
+      </p:sp>
       <p:sp>
         <p:nvSpPr>
           <p:cNvPr id="2" name="Title 1"/>
@@ -4318,10 +4977,15 @@
             <p:ph type="title"/>
           </p:nvPr>
         </p:nvSpPr>
-        <p:spPr/>
+        <p:spPr>
+          <a:xfrm>
+            <a:off x="946404" y="365760"/>
+            <a:ext cx="7269480" cy="1325562"/>
+          </a:xfrm>
+        </p:spPr>
         <p:txBody>
           <a:bodyPr>
-            <a:normAutofit fontScale="90000"/>
+            <a:normAutofit/>
           </a:bodyPr>
           <a:lstStyle/>
           <a:p>
@@ -4341,158 +5005,201 @@
             <p:ph idx="1"/>
           </p:nvPr>
         </p:nvSpPr>
-        <p:spPr/>
+        <p:spPr>
+          <a:xfrm>
+            <a:off x="946404" y="1920240"/>
+            <a:ext cx="6446520" cy="4351337"/>
+          </a:xfrm>
+        </p:spPr>
         <p:txBody>
           <a:bodyPr>
-            <a:normAutofit fontScale="77500" lnSpcReduction="20000"/>
+            <a:normAutofit/>
           </a:bodyPr>
           <a:lstStyle/>
           <a:p>
             <a:r>
+              <a:rPr lang="en-US" sz="1500" dirty="0"/>
               <a:t>Lessons Learned:</a:t>
             </a:r>
           </a:p>
           <a:p>
             <a:r>
+              <a:rPr lang="en-US" sz="1500" dirty="0"/>
               <a:t>- CNNs are effective for image classification tasks.</a:t>
             </a:r>
           </a:p>
           <a:p>
             <a:r>
+              <a:rPr lang="en-US" sz="1500" dirty="0"/>
               <a:t>- Small parameter changes can significantly impact performance.</a:t>
             </a:r>
           </a:p>
           <a:p>
             <a:r>
+              <a:rPr lang="en-US" sz="1500" dirty="0"/>
               <a:t>- Proper tuning improves both accuracy and model generalization.</a:t>
             </a:r>
           </a:p>
           <a:p>
-            <a:endParaRPr/>
-          </a:p>
-          <a:p>
-            <a:r>
+            <a:endParaRPr lang="en-US" sz="1500" dirty="0"/>
+          </a:p>
+          <a:p>
+            <a:r>
+              <a:rPr lang="en-US" sz="1500" dirty="0"/>
               <a:t>Future Improvements:</a:t>
             </a:r>
           </a:p>
           <a:p>
             <a:r>
+              <a:rPr lang="en-US" sz="1500" dirty="0"/>
               <a:t>- Experiment with deeper CNN architectures</a:t>
             </a:r>
           </a:p>
           <a:p>
             <a:r>
+              <a:rPr lang="en-US" sz="1500" dirty="0"/>
               <a:t>- Use data augmentation techniques</a:t>
             </a:r>
           </a:p>
           <a:p>
             <a:r>
+              <a:rPr lang="en-US" sz="1500" dirty="0"/>
               <a:t>- Try different optimizers and learning rates</a:t>
             </a:r>
           </a:p>
           <a:p>
             <a:r>
+              <a:rPr lang="en-US" sz="1500" dirty="0"/>
               <a:t>- Train for additional epochs with early stopping</a:t>
             </a:r>
+          </a:p>
+        </p:txBody>
+      </p:sp>
+      <p:sp>
+        <p:nvSpPr>
+          <p:cNvPr id="10" name="Rectangle 9">
+            <a:extLst>
+              <a:ext uri="{FF2B5EF4-FFF2-40B4-BE49-F238E27FC236}">
+                <a16:creationId xmlns:a16="http://schemas.microsoft.com/office/drawing/2014/main" id="{6B424749-EEE0-49C9-9ABF-97B171A3EA00}"/>
+              </a:ext>
+              <a:ext uri="{C183D7F6-B498-43B3-948B-1728B52AA6E4}">
+                <adec:decorative xmlns:adec="http://schemas.microsoft.com/office/drawing/2017/decorative" val="1"/>
+              </a:ext>
+            </a:extLst>
+          </p:cNvPr>
+          <p:cNvSpPr>
+            <a:spLocks noGrp="1" noRot="1" noChangeAspect="1" noMove="1" noResize="1" noEditPoints="1" noAdjustHandles="1" noChangeArrowheads="1" noChangeShapeType="1" noTextEdit="1"/>
+          </p:cNvSpPr>
+          <p:nvPr>
+            <p:extLst>
+              <p:ext uri="{386F3935-93C4-4BCD-93E2-E3B085C9AB24}">
+                <p16:designElem xmlns:p16="http://schemas.microsoft.com/office/powerpoint/2015/main" val="1"/>
+              </p:ext>
+            </p:extLst>
+          </p:nvPr>
+        </p:nvSpPr>
+        <p:spPr>
+          <a:xfrm>
+            <a:off x="8458200" y="0"/>
+            <a:ext cx="685800" cy="6858000"/>
+          </a:xfrm>
+          <a:prstGeom prst="rect">
+            <a:avLst/>
+          </a:prstGeom>
+          <a:solidFill>
+            <a:schemeClr val="tx2">
+              <a:lumMod val="75000"/>
+            </a:schemeClr>
+          </a:solidFill>
+          <a:ln>
+            <a:noFill/>
+          </a:ln>
+        </p:spPr>
+        <p:style>
+          <a:lnRef idx="2">
+            <a:schemeClr val="accent1">
+              <a:shade val="50000"/>
+            </a:schemeClr>
+          </a:lnRef>
+          <a:fillRef idx="1">
+            <a:schemeClr val="accent1"/>
+          </a:fillRef>
+          <a:effectRef idx="0">
+            <a:schemeClr val="accent1"/>
+          </a:effectRef>
+          <a:fontRef idx="minor">
+            <a:schemeClr val="lt1"/>
+          </a:fontRef>
+        </p:style>
+        <p:txBody>
+          <a:bodyPr/>
+          <a:lstStyle/>
+          <a:p>
+            <a:endParaRPr lang="en-US"/>
           </a:p>
         </p:txBody>
       </p:sp>
     </p:spTree>
   </p:cSld>
   <p:clrMapOvr>
-    <a:masterClrMapping/>
+    <a:overrideClrMapping bg1="dk1" tx1="lt1" bg2="dk2" tx2="lt2" accent1="accent1" accent2="accent2" accent3="accent3" accent4="accent4" accent5="accent5" accent6="accent6" hlink="hlink" folHlink="folHlink"/>
   </p:clrMapOvr>
 </p:sld>
 </file>
 
 <file path=ppt/theme/theme1.xml><?xml version="1.0" encoding="utf-8"?>
-<a:theme xmlns:a="http://schemas.openxmlformats.org/drawingml/2006/main" name="Office Theme">
+<a:theme xmlns:a="http://schemas.openxmlformats.org/drawingml/2006/main" name="View">
   <a:themeElements>
-    <a:clrScheme name="Office">
+    <a:clrScheme name="View">
       <a:dk1>
-        <a:sysClr val="windowText" lastClr="000000"/>
+        <a:srgbClr val="000000"/>
       </a:dk1>
       <a:lt1>
-        <a:sysClr val="window" lastClr="FFFFFF"/>
+        <a:srgbClr val="FFFFFF"/>
       </a:lt1>
       <a:dk2>
-        <a:srgbClr val="1F497D"/>
+        <a:srgbClr val="46464A"/>
       </a:dk2>
       <a:lt2>
-        <a:srgbClr val="EEECE1"/>
+        <a:srgbClr val="D6D3CC"/>
       </a:lt2>
       <a:accent1>
-        <a:srgbClr val="4F81BD"/>
+        <a:srgbClr val="6F6F74"/>
       </a:accent1>
       <a:accent2>
-        <a:srgbClr val="C0504D"/>
+        <a:srgbClr val="92A9B9"/>
       </a:accent2>
       <a:accent3>
-        <a:srgbClr val="9BBB59"/>
+        <a:srgbClr val="A7B789"/>
       </a:accent3>
       <a:accent4>
-        <a:srgbClr val="8064A2"/>
+        <a:srgbClr val="B9A489"/>
       </a:accent4>
       <a:accent5>
-        <a:srgbClr val="4BACC6"/>
+        <a:srgbClr val="8D6374"/>
       </a:accent5>
       <a:accent6>
-        <a:srgbClr val="F79646"/>
+        <a:srgbClr val="9B7362"/>
       </a:accent6>
       <a:hlink>
-        <a:srgbClr val="0000FF"/>
+        <a:srgbClr val="67AABF"/>
       </a:hlink>
       <a:folHlink>
-        <a:srgbClr val="800080"/>
+        <a:srgbClr val="ABAFA5"/>
       </a:folHlink>
     </a:clrScheme>
-    <a:fontScheme name="Office">
+    <a:fontScheme name="View">
       <a:majorFont>
-        <a:latin typeface="Calibri"/>
+        <a:latin typeface="Century Schoolbook" panose="02040604050505020304"/>
         <a:ea typeface=""/>
         <a:cs typeface=""/>
-        <a:font script="Jpan" typeface="ＭＳ Ｐゴシック"/>
+        <a:font script="Jpan" typeface="ＭＳ ゴシック"/>
         <a:font script="Hang" typeface="맑은 고딕"/>
         <a:font script="Hans" typeface="宋体"/>
         <a:font script="Hant" typeface="新細明體"/>
-        <a:font script="Arab" typeface="Times New Roman"/>
-        <a:font script="Hebr" typeface="Times New Roman"/>
-        <a:font script="Thai" typeface="Angsana New"/>
-        <a:font script="Ethi" typeface="Nyala"/>
-        <a:font script="Beng" typeface="Vrinda"/>
-        <a:font script="Gujr" typeface="Shruti"/>
-        <a:font script="Khmr" typeface="MoolBoran"/>
-        <a:font script="Knda" typeface="Tunga"/>
-        <a:font script="Guru" typeface="Raavi"/>
-        <a:font script="Cans" typeface="Euphemia"/>
-        <a:font script="Cher" typeface="Plantagenet Cherokee"/>
-        <a:font script="Yiii" typeface="Microsoft Yi Baiti"/>
-        <a:font script="Tibt" typeface="Microsoft Himalaya"/>
-        <a:font script="Thaa" typeface="MV Boli"/>
-        <a:font script="Deva" typeface="Mangal"/>
-        <a:font script="Telu" typeface="Gautami"/>
-        <a:font script="Taml" typeface="Latha"/>
-        <a:font script="Syrc" typeface="Estrangelo Edessa"/>
-        <a:font script="Orya" typeface="Kalinga"/>
-        <a:font script="Mlym" typeface="Kartika"/>
-        <a:font script="Laoo" typeface="DokChampa"/>
-        <a:font script="Sinh" typeface="Iskoola Pota"/>
-        <a:font script="Mong" typeface="Mongolian Baiti"/>
-        <a:font script="Viet" typeface="Times New Roman"/>
-        <a:font script="Uigh" typeface="Microsoft Uighur"/>
-        <a:font script="Geor" typeface="Sylfaen"/>
-      </a:majorFont>
-      <a:minorFont>
-        <a:latin typeface="Calibri"/>
-        <a:ea typeface=""/>
-        <a:cs typeface=""/>
-        <a:font script="Jpan" typeface="ＭＳ Ｐゴシック"/>
-        <a:font script="Hang" typeface="맑은 고딕"/>
-        <a:font script="Hans" typeface="宋体"/>
-        <a:font script="Hant" typeface="新細明體"/>
-        <a:font script="Arab" typeface="Arial"/>
-        <a:font script="Hebr" typeface="Arial"/>
-        <a:font script="Thai" typeface="Cordia New"/>
+        <a:font script="Arab" typeface="Tahoma"/>
+        <a:font script="Hebr" typeface="Gisha"/>
+        <a:font script="Thai" typeface="DilleniaUPC"/>
         <a:font script="Ethi" typeface="Nyala"/>
         <a:font script="Beng" typeface="Vrinda"/>
         <a:font script="Gujr" typeface="Shruti"/>
@@ -4513,106 +5220,97 @@
         <a:font script="Laoo" typeface="DokChampa"/>
         <a:font script="Sinh" typeface="Iskoola Pota"/>
         <a:font script="Mong" typeface="Mongolian Baiti"/>
-        <a:font script="Viet" typeface="Arial"/>
+        <a:font script="Viet" typeface="Tahoma"/>
+        <a:font script="Uigh" typeface="Microsoft Uighur"/>
+        <a:font script="Geor" typeface="Sylfaen"/>
+      </a:majorFont>
+      <a:minorFont>
+        <a:latin typeface="Century Schoolbook" panose="02040604050505020304"/>
+        <a:ea typeface=""/>
+        <a:cs typeface=""/>
+        <a:font script="Jpan" typeface="ＭＳ ゴシック"/>
+        <a:font script="Hang" typeface="맑은 고딕"/>
+        <a:font script="Hans" typeface="宋体"/>
+        <a:font script="Hant" typeface="新細明體"/>
+        <a:font script="Arab" typeface="Tahoma"/>
+        <a:font script="Hebr" typeface="Gisha"/>
+        <a:font script="Thai" typeface="DilleniaUPC"/>
+        <a:font script="Ethi" typeface="Nyala"/>
+        <a:font script="Beng" typeface="Vrinda"/>
+        <a:font script="Gujr" typeface="Shruti"/>
+        <a:font script="Khmr" typeface="DaunPenh"/>
+        <a:font script="Knda" typeface="Tunga"/>
+        <a:font script="Guru" typeface="Raavi"/>
+        <a:font script="Cans" typeface="Euphemia"/>
+        <a:font script="Cher" typeface="Plantagenet Cherokee"/>
+        <a:font script="Yiii" typeface="Microsoft Yi Baiti"/>
+        <a:font script="Tibt" typeface="Microsoft Himalaya"/>
+        <a:font script="Thaa" typeface="MV Boli"/>
+        <a:font script="Deva" typeface="Mangal"/>
+        <a:font script="Telu" typeface="Gautami"/>
+        <a:font script="Taml" typeface="Latha"/>
+        <a:font script="Syrc" typeface="Estrangelo Edessa"/>
+        <a:font script="Orya" typeface="Kalinga"/>
+        <a:font script="Mlym" typeface="Kartika"/>
+        <a:font script="Laoo" typeface="DokChampa"/>
+        <a:font script="Sinh" typeface="Iskoola Pota"/>
+        <a:font script="Mong" typeface="Mongolian Baiti"/>
+        <a:font script="Viet" typeface="Verdana"/>
         <a:font script="Uigh" typeface="Microsoft Uighur"/>
         <a:font script="Geor" typeface="Sylfaen"/>
       </a:minorFont>
     </a:fontScheme>
-    <a:fmtScheme name="Office">
+    <a:fmtScheme name="View">
       <a:fillStyleLst>
         <a:solidFill>
           <a:schemeClr val="phClr"/>
         </a:solidFill>
-        <a:gradFill rotWithShape="1">
-          <a:gsLst>
-            <a:gs pos="0">
-              <a:schemeClr val="phClr">
-                <a:tint val="50000"/>
-                <a:satMod val="300000"/>
-              </a:schemeClr>
-            </a:gs>
-            <a:gs pos="35000">
-              <a:schemeClr val="phClr">
-                <a:tint val="37000"/>
-                <a:satMod val="300000"/>
-              </a:schemeClr>
-            </a:gs>
-            <a:gs pos="100000">
-              <a:schemeClr val="phClr">
-                <a:tint val="15000"/>
-                <a:satMod val="350000"/>
-              </a:schemeClr>
-            </a:gs>
-          </a:gsLst>
-          <a:lin ang="16200000" scaled="1"/>
-        </a:gradFill>
-        <a:gradFill rotWithShape="1">
-          <a:gsLst>
-            <a:gs pos="0">
-              <a:schemeClr val="phClr">
-                <a:tint val="100000"/>
-                <a:shade val="100000"/>
-                <a:satMod val="130000"/>
-              </a:schemeClr>
-            </a:gs>
-            <a:gs pos="100000">
-              <a:schemeClr val="phClr">
-                <a:tint val="50000"/>
-                <a:shade val="100000"/>
-                <a:satMod val="350000"/>
-              </a:schemeClr>
-            </a:gs>
-          </a:gsLst>
-          <a:lin ang="16200000" scaled="0"/>
-        </a:gradFill>
+        <a:solidFill>
+          <a:schemeClr val="phClr">
+            <a:tint val="60000"/>
+            <a:satMod val="120000"/>
+          </a:schemeClr>
+        </a:solidFill>
+        <a:solidFill>
+          <a:schemeClr val="phClr">
+            <a:shade val="75000"/>
+            <a:satMod val="160000"/>
+          </a:schemeClr>
+        </a:solidFill>
       </a:fillStyleLst>
       <a:lnStyleLst>
         <a:ln w="9525" cap="flat" cmpd="sng" algn="ctr">
-          <a:solidFill>
-            <a:schemeClr val="phClr">
-              <a:shade val="95000"/>
-              <a:satMod val="105000"/>
-            </a:schemeClr>
-          </a:solidFill>
-          <a:prstDash val="solid"/>
-        </a:ln>
-        <a:ln w="25400" cap="flat" cmpd="sng" algn="ctr">
           <a:solidFill>
             <a:schemeClr val="phClr"/>
           </a:solidFill>
           <a:prstDash val="solid"/>
         </a:ln>
-        <a:ln w="38100" cap="flat" cmpd="sng" algn="ctr">
+        <a:ln w="13970" cap="flat" cmpd="sng" algn="ctr">
           <a:solidFill>
             <a:schemeClr val="phClr"/>
+          </a:solidFill>
+          <a:prstDash val="solid"/>
+        </a:ln>
+        <a:ln w="17145" cap="flat" cmpd="sng" algn="ctr">
+          <a:solidFill>
+            <a:schemeClr val="phClr">
+              <a:shade val="95000"/>
+              <a:alpha val="95000"/>
+              <a:satMod val="150000"/>
+            </a:schemeClr>
           </a:solidFill>
           <a:prstDash val="solid"/>
         </a:ln>
       </a:lnStyleLst>
       <a:effectStyleLst>
         <a:effectStyle>
-          <a:effectLst>
-            <a:outerShdw blurRad="40000" dist="20000" dir="5400000" rotWithShape="0">
-              <a:srgbClr val="000000">
-                <a:alpha val="38000"/>
-              </a:srgbClr>
-            </a:outerShdw>
-          </a:effectLst>
+          <a:effectLst/>
         </a:effectStyle>
         <a:effectStyle>
           <a:effectLst>
-            <a:outerShdw blurRad="40000" dist="23000" dir="5400000" rotWithShape="0">
+            <a:outerShdw blurRad="50800" dist="15240" dir="5400000" algn="tl" rotWithShape="0">
               <a:srgbClr val="000000">
-                <a:alpha val="35000"/>
-              </a:srgbClr>
-            </a:outerShdw>
-          </a:effectLst>
-        </a:effectStyle>
-        <a:effectStyle>
-          <a:effectLst>
-            <a:outerShdw blurRad="40000" dist="23000" dir="5400000" rotWithShape="0">
-              <a:srgbClr val="000000">
-                <a:alpha val="35000"/>
+                <a:alpha val="75000"/>
               </a:srgbClr>
             </a:outerShdw>
           </a:effectLst>
@@ -4620,12 +5318,40 @@
             <a:camera prst="orthographicFront">
               <a:rot lat="0" lon="0" rev="0"/>
             </a:camera>
-            <a:lightRig rig="threePt" dir="t">
-              <a:rot lat="0" lon="0" rev="1200000"/>
-            </a:lightRig>
+            <a:lightRig rig="brightRoom" dir="tl"/>
           </a:scene3d>
-          <a:sp3d>
-            <a:bevelT w="63500" h="25400"/>
+          <a:sp3d contourW="9525" prstMaterial="flat">
+            <a:bevelT w="0" h="0" prst="coolSlant"/>
+            <a:contourClr>
+              <a:schemeClr val="phClr">
+                <a:shade val="35000"/>
+                <a:satMod val="130000"/>
+              </a:schemeClr>
+            </a:contourClr>
+          </a:sp3d>
+        </a:effectStyle>
+        <a:effectStyle>
+          <a:effectLst>
+            <a:outerShdw blurRad="76200" dist="25400" dir="5400000" algn="tl" rotWithShape="0">
+              <a:srgbClr val="000000">
+                <a:alpha val="55000"/>
+              </a:srgbClr>
+            </a:outerShdw>
+          </a:effectLst>
+          <a:scene3d>
+            <a:camera prst="orthographicFront">
+              <a:rot lat="0" lon="0" rev="0"/>
+            </a:camera>
+            <a:lightRig rig="brightRoom" dir="tl"/>
+          </a:scene3d>
+          <a:sp3d contourW="19050" prstMaterial="flat">
+            <a:bevelT w="0" h="0" prst="coolSlant"/>
+            <a:contourClr>
+              <a:schemeClr val="phClr">
+                <a:shade val="25000"/>
+                <a:satMod val="140000"/>
+              </a:schemeClr>
+            </a:contourClr>
           </a:sp3d>
         </a:effectStyle>
       </a:effectStyleLst>
@@ -4633,94 +5359,43 @@
         <a:solidFill>
           <a:schemeClr val="phClr"/>
         </a:solidFill>
+        <a:solidFill>
+          <a:schemeClr val="phClr">
+            <a:tint val="95000"/>
+            <a:satMod val="170000"/>
+          </a:schemeClr>
+        </a:solidFill>
         <a:gradFill rotWithShape="1">
           <a:gsLst>
             <a:gs pos="0">
               <a:schemeClr val="phClr">
-                <a:tint val="40000"/>
-                <a:satMod val="350000"/>
-              </a:schemeClr>
-            </a:gs>
-            <a:gs pos="40000">
-              <a:schemeClr val="phClr">
-                <a:tint val="45000"/>
-                <a:shade val="99000"/>
-                <a:satMod val="350000"/>
+                <a:tint val="94000"/>
+                <a:shade val="98000"/>
+                <a:satMod val="130000"/>
+                <a:lumMod val="102000"/>
               </a:schemeClr>
             </a:gs>
             <a:gs pos="100000">
               <a:schemeClr val="phClr">
-                <a:shade val="20000"/>
-                <a:satMod val="255000"/>
+                <a:tint val="98000"/>
+                <a:shade val="78000"/>
+                <a:satMod val="140000"/>
               </a:schemeClr>
             </a:gs>
           </a:gsLst>
           <a:path path="circle">
-            <a:fillToRect l="50000" t="-80000" r="50000" b="180000"/>
-          </a:path>
-        </a:gradFill>
-        <a:gradFill rotWithShape="1">
-          <a:gsLst>
-            <a:gs pos="0">
-              <a:schemeClr val="phClr">
-                <a:tint val="80000"/>
-                <a:satMod val="300000"/>
-              </a:schemeClr>
-            </a:gs>
-            <a:gs pos="100000">
-              <a:schemeClr val="phClr">
-                <a:shade val="30000"/>
-                <a:satMod val="200000"/>
-              </a:schemeClr>
-            </a:gs>
-          </a:gsLst>
-          <a:path path="circle">
-            <a:fillToRect l="50000" t="50000" r="50000" b="50000"/>
+            <a:fillToRect l="100000" t="100000" r="100000" b="100000"/>
           </a:path>
         </a:gradFill>
       </a:bgFillStyleLst>
     </a:fmtScheme>
   </a:themeElements>
-  <a:objectDefaults>
-    <a:spDef>
-      <a:spPr/>
-      <a:bodyPr/>
-      <a:lstStyle/>
-      <a:style>
-        <a:lnRef idx="1">
-          <a:schemeClr val="accent1"/>
-        </a:lnRef>
-        <a:fillRef idx="3">
-          <a:schemeClr val="accent1"/>
-        </a:fillRef>
-        <a:effectRef idx="2">
-          <a:schemeClr val="accent1"/>
-        </a:effectRef>
-        <a:fontRef idx="minor">
-          <a:schemeClr val="lt1"/>
-        </a:fontRef>
-      </a:style>
-    </a:spDef>
-    <a:lnDef>
-      <a:spPr/>
-      <a:bodyPr/>
-      <a:lstStyle/>
-      <a:style>
-        <a:lnRef idx="2">
-          <a:schemeClr val="accent1"/>
-        </a:lnRef>
-        <a:fillRef idx="0">
-          <a:schemeClr val="accent1"/>
-        </a:fillRef>
-        <a:effectRef idx="1">
-          <a:schemeClr val="accent1"/>
-        </a:effectRef>
-        <a:fontRef idx="minor">
-          <a:schemeClr val="tx1"/>
-        </a:fontRef>
-      </a:style>
-    </a:lnDef>
-  </a:objectDefaults>
+  <a:objectDefaults/>
   <a:extraClrSchemeLst/>
+  <a:extLst>
+    <a:ext uri="{05A4C25C-085E-4340-85A3-A5531E510DB2}">
+      <thm15:themeFamily xmlns:thm15="http://schemas.microsoft.com/office/thememl/2012/main" name="View" id="{BA0EB5A6-F2D4-4F82-977B-64ADEE4A2A69}" vid="{3969A8A2-35DB-4E3B-8885-16FD20568674}"/>
+    </a:ext>
+  </a:extLst>
 </a:theme>
 </file>
</xml_diff>

<commit_message>
Changes for final push.
</commit_message>
<xml_diff>
--- a/IN501_Ridenour_Kresser_Meadows_Mpianin_Galarza_Unit9_Assignment.pptx
+++ b/IN501_Ridenour_Kresser_Meadows_Mpianin_Galarza_Unit9_Assignment.pptx
@@ -353,6 +353,13 @@
             <a:schemeClr val="lt1"/>
           </a:fontRef>
         </p:style>
+        <p:txBody>
+          <a:bodyPr/>
+          <a:lstStyle/>
+          <a:p>
+            <a:endParaRPr lang="en-US"/>
+          </a:p>
+        </p:txBody>
       </p:sp>
       <p:sp>
         <p:nvSpPr>
@@ -382,7 +389,7 @@
           <a:p>
             <a:fld id="{5BCAD085-E8A6-8845-BD4E-CB4CCA059FC4}" type="datetimeFigureOut">
               <a:rPr lang="en-US" smtClean="0"/>
-              <a:t>3/9/2026</a:t>
+              <a:t>3/10/2026</a:t>
             </a:fld>
             <a:endParaRPr lang="en-US"/>
           </a:p>
@@ -574,7 +581,7 @@
           <a:p>
             <a:fld id="{5BCAD085-E8A6-8845-BD4E-CB4CCA059FC4}" type="datetimeFigureOut">
               <a:rPr lang="en-US" smtClean="0"/>
-              <a:t>3/9/2026</a:t>
+              <a:t>3/10/2026</a:t>
             </a:fld>
             <a:endParaRPr lang="en-US"/>
           </a:p>
@@ -754,7 +761,7 @@
           <a:p>
             <a:fld id="{5BCAD085-E8A6-8845-BD4E-CB4CCA059FC4}" type="datetimeFigureOut">
               <a:rPr lang="en-US" smtClean="0"/>
-              <a:t>3/9/2026</a:t>
+              <a:t>3/10/2026</a:t>
             </a:fld>
             <a:endParaRPr lang="en-US"/>
           </a:p>
@@ -924,7 +931,7 @@
           <a:p>
             <a:fld id="{5BCAD085-E8A6-8845-BD4E-CB4CCA059FC4}" type="datetimeFigureOut">
               <a:rPr lang="en-US" smtClean="0"/>
-              <a:t>3/9/2026</a:t>
+              <a:t>3/10/2026</a:t>
             </a:fld>
             <a:endParaRPr lang="en-US"/>
           </a:p>
@@ -1178,7 +1185,7 @@
           <a:p>
             <a:fld id="{5BCAD085-E8A6-8845-BD4E-CB4CCA059FC4}" type="datetimeFigureOut">
               <a:rPr lang="en-US" smtClean="0"/>
-              <a:t>3/9/2026</a:t>
+              <a:t>3/10/2026</a:t>
             </a:fld>
             <a:endParaRPr lang="en-US"/>
           </a:p>
@@ -1504,7 +1511,7 @@
           <a:p>
             <a:fld id="{5BCAD085-E8A6-8845-BD4E-CB4CCA059FC4}" type="datetimeFigureOut">
               <a:rPr lang="en-US" smtClean="0"/>
-              <a:t>3/9/2026</a:t>
+              <a:t>3/10/2026</a:t>
             </a:fld>
             <a:endParaRPr lang="en-US"/>
           </a:p>
@@ -1924,7 +1931,7 @@
           <a:p>
             <a:fld id="{5BCAD085-E8A6-8845-BD4E-CB4CCA059FC4}" type="datetimeFigureOut">
               <a:rPr lang="en-US" smtClean="0"/>
-              <a:t>3/9/2026</a:t>
+              <a:t>3/10/2026</a:t>
             </a:fld>
             <a:endParaRPr lang="en-US"/>
           </a:p>
@@ -2042,7 +2049,7 @@
           <a:p>
             <a:fld id="{5BCAD085-E8A6-8845-BD4E-CB4CCA059FC4}" type="datetimeFigureOut">
               <a:rPr lang="en-US" smtClean="0"/>
-              <a:t>3/9/2026</a:t>
+              <a:t>3/10/2026</a:t>
             </a:fld>
             <a:endParaRPr lang="en-US"/>
           </a:p>
@@ -2137,7 +2144,7 @@
           <a:p>
             <a:fld id="{5BCAD085-E8A6-8845-BD4E-CB4CCA059FC4}" type="datetimeFigureOut">
               <a:rPr lang="en-US" smtClean="0"/>
-              <a:t>3/9/2026</a:t>
+              <a:t>3/10/2026</a:t>
             </a:fld>
             <a:endParaRPr lang="en-US"/>
           </a:p>
@@ -2424,7 +2431,7 @@
           <a:p>
             <a:fld id="{5BCAD085-E8A6-8845-BD4E-CB4CCA059FC4}" type="datetimeFigureOut">
               <a:rPr lang="en-US" smtClean="0"/>
-              <a:t>3/9/2026</a:t>
+              <a:t>3/10/2026</a:t>
             </a:fld>
             <a:endParaRPr lang="en-US"/>
           </a:p>
@@ -2746,7 +2753,7 @@
           <a:p>
             <a:fld id="{5BCAD085-E8A6-8845-BD4E-CB4CCA059FC4}" type="datetimeFigureOut">
               <a:rPr lang="en-US" smtClean="0"/>
-              <a:t>3/9/2026</a:t>
+              <a:t>3/10/2026</a:t>
             </a:fld>
             <a:endParaRPr lang="en-US"/>
           </a:p>
@@ -2868,6 +2875,13 @@
             <a:schemeClr val="lt1"/>
           </a:fontRef>
         </p:style>
+        <p:txBody>
+          <a:bodyPr/>
+          <a:lstStyle/>
+          <a:p>
+            <a:endParaRPr lang="en-US"/>
+          </a:p>
+        </p:txBody>
       </p:sp>
       <p:sp>
         <p:nvSpPr>
@@ -3000,7 +3014,7 @@
           <a:p>
             <a:fld id="{5BCAD085-E8A6-8845-BD4E-CB4CCA059FC4}" type="datetimeFigureOut">
               <a:rPr lang="en-US" smtClean="0"/>
-              <a:t>3/9/2026</a:t>
+              <a:t>3/10/2026</a:t>
             </a:fld>
             <a:endParaRPr lang="en-US"/>
           </a:p>
@@ -3837,7 +3851,7 @@
         </p:spPr>
         <p:txBody>
           <a:bodyPr>
-            <a:normAutofit fontScale="92500" lnSpcReduction="10000"/>
+            <a:normAutofit fontScale="85000" lnSpcReduction="10000"/>
           </a:bodyPr>
           <a:lstStyle/>
           <a:p>
@@ -3886,6 +3900,14 @@
               <a:rPr dirty="0"/>
               <a:t>Results:</a:t>
             </a:r>
+            <a:endParaRPr lang="en-US" dirty="0"/>
+          </a:p>
+          <a:p>
+            <a:r>
+              <a:rPr lang="en-US" dirty="0"/>
+              <a:t>Total Loss: 0.0316</a:t>
+            </a:r>
+            <a:endParaRPr dirty="0"/>
           </a:p>
           <a:p>
             <a:r>
@@ -3909,7 +3931,7 @@
             </a:r>
             <a:r>
               <a:rPr lang="en-US" dirty="0"/>
-              <a:t>: Increased accuracy of 0.0024</a:t>
+              <a:t>: Increased accuracy of 0.0039, decreased loss by 0.0087</a:t>
             </a:r>
             <a:endParaRPr dirty="0">
               <a:highlight>
@@ -3984,7 +4006,7 @@
         </p:spPr>
         <p:txBody>
           <a:bodyPr>
-            <a:normAutofit fontScale="92500" lnSpcReduction="10000"/>
+            <a:normAutofit fontScale="85000" lnSpcReduction="20000"/>
           </a:bodyPr>
           <a:lstStyle/>
           <a:p>
@@ -4033,6 +4055,14 @@
               <a:rPr dirty="0"/>
               <a:t>Results:</a:t>
             </a:r>
+            <a:endParaRPr lang="en-US" dirty="0"/>
+          </a:p>
+          <a:p>
+            <a:r>
+              <a:rPr lang="en-US" dirty="0"/>
+              <a:t>Total Loss: 0.0249</a:t>
+            </a:r>
+            <a:endParaRPr dirty="0"/>
           </a:p>
           <a:p>
             <a:r>
@@ -4041,7 +4071,7 @@
             </a:r>
             <a:r>
               <a:rPr lang="en-US" dirty="0"/>
-              <a:t>0.9924</a:t>
+              <a:t>0.9922</a:t>
             </a:r>
             <a:endParaRPr dirty="0"/>
           </a:p>
@@ -4052,7 +4082,7 @@
             </a:r>
             <a:r>
               <a:rPr lang="en-US" dirty="0"/>
-              <a:t>Increased accuracy of .0041</a:t>
+              <a:t>Decreased accuracy by 0.0008, decreased loss by 0.0067</a:t>
             </a:r>
             <a:endParaRPr dirty="0"/>
           </a:p>
@@ -4122,7 +4152,7 @@
         </p:spPr>
         <p:txBody>
           <a:bodyPr>
-            <a:normAutofit fontScale="92500" lnSpcReduction="10000"/>
+            <a:normAutofit fontScale="85000" lnSpcReduction="20000"/>
           </a:bodyPr>
           <a:lstStyle/>
           <a:p>
@@ -4175,33 +4205,25 @@
               <a:rPr dirty="0"/>
               <a:t>Results:</a:t>
             </a:r>
-          </a:p>
-          <a:p>
-            <a:r>
-              <a:rPr dirty="0"/>
-              <a:t>Accuracy: </a:t>
-            </a:r>
-            <a:r>
-              <a:rPr dirty="0">
-                <a:highlight>
-                  <a:srgbClr val="FFFF00"/>
-                </a:highlight>
-              </a:rPr>
-              <a:t>(Insert result)</a:t>
-            </a:r>
-          </a:p>
-          <a:p>
-            <a:r>
-              <a:rPr dirty="0"/>
-              <a:t>Observation: </a:t>
-            </a:r>
-            <a:r>
-              <a:rPr dirty="0">
-                <a:highlight>
-                  <a:srgbClr val="FFFF00"/>
-                </a:highlight>
-              </a:rPr>
-              <a:t>(Insert comparison)</a:t>
+            <a:endParaRPr lang="en-US" dirty="0"/>
+          </a:p>
+          <a:p>
+            <a:r>
+              <a:rPr lang="en-US" dirty="0"/>
+              <a:t>Total Loss: 0.02839</a:t>
+            </a:r>
+            <a:endParaRPr dirty="0"/>
+          </a:p>
+          <a:p>
+            <a:r>
+              <a:rPr lang="en-US" dirty="0"/>
+              <a:t>Accuracy: 0.9914</a:t>
+            </a:r>
+          </a:p>
+          <a:p>
+            <a:r>
+              <a:rPr lang="en-US" dirty="0"/>
+              <a:t>Observation: Increased accuracy by 0.0015, increased loss by 0.00339</a:t>
             </a:r>
           </a:p>
         </p:txBody>
@@ -4270,7 +4292,7 @@
         </p:spPr>
         <p:txBody>
           <a:bodyPr>
-            <a:normAutofit lnSpcReduction="10000"/>
+            <a:normAutofit fontScale="92500" lnSpcReduction="20000"/>
           </a:bodyPr>
           <a:lstStyle/>
           <a:p>
@@ -4312,33 +4334,25 @@
               <a:rPr dirty="0"/>
               <a:t>Results:</a:t>
             </a:r>
-          </a:p>
-          <a:p>
-            <a:r>
-              <a:rPr dirty="0"/>
-              <a:t>Accuracy: </a:t>
-            </a:r>
-            <a:r>
-              <a:rPr dirty="0">
-                <a:highlight>
-                  <a:srgbClr val="FFFF00"/>
-                </a:highlight>
-              </a:rPr>
-              <a:t>(Insert result)</a:t>
-            </a:r>
-          </a:p>
-          <a:p>
-            <a:r>
-              <a:rPr dirty="0"/>
-              <a:t>Observation: </a:t>
-            </a:r>
-            <a:r>
-              <a:rPr dirty="0">
-                <a:highlight>
-                  <a:srgbClr val="FFFF00"/>
-                </a:highlight>
-              </a:rPr>
-              <a:t>(Insert comparison)</a:t>
+            <a:endParaRPr lang="en-US" dirty="0"/>
+          </a:p>
+          <a:p>
+            <a:r>
+              <a:rPr lang="en-US" dirty="0"/>
+              <a:t>Total Loss: 0.04337</a:t>
+            </a:r>
+            <a:endParaRPr dirty="0"/>
+          </a:p>
+          <a:p>
+            <a:r>
+              <a:rPr lang="en-US" dirty="0"/>
+              <a:t>Accuracy: 0.9859</a:t>
+            </a:r>
+          </a:p>
+          <a:p>
+            <a:r>
+              <a:rPr lang="en-US" dirty="0"/>
+              <a:t>Observation: Decreased accuracy by 0.0055, increased loss by 0.01508</a:t>
             </a:r>
           </a:p>
         </p:txBody>
@@ -4409,7 +4423,7 @@
         </p:spPr>
         <p:txBody>
           <a:bodyPr>
-            <a:normAutofit/>
+            <a:normAutofit fontScale="92500" lnSpcReduction="20000"/>
           </a:bodyPr>
           <a:lstStyle/>
           <a:p>
@@ -4460,27 +4474,26 @@
               <a:rPr dirty="0"/>
               <a:t>Results:</a:t>
             </a:r>
-          </a:p>
-          <a:p>
-            <a:r>
-              <a:rPr dirty="0"/>
-              <a:t>Accuracy: </a:t>
-            </a:r>
+            <a:endParaRPr lang="en-US" dirty="0"/>
+          </a:p>
+          <a:p>
             <a:r>
               <a:rPr lang="en-US" dirty="0"/>
-              <a:t>0.9871 </a:t>
-            </a:r>
-          </a:p>
-          <a:p>
-            <a:r>
-              <a:rPr dirty="0"/>
-              <a:t>Observation: </a:t>
-            </a:r>
+              <a:t>Total Loss: 0.0599</a:t>
+            </a:r>
+            <a:endParaRPr dirty="0"/>
+          </a:p>
+          <a:p>
             <a:r>
               <a:rPr lang="en-US" dirty="0"/>
-              <a:t>Decrease accuracy of 0.0012</a:t>
-            </a:r>
-            <a:endParaRPr dirty="0"/>
+              <a:t>Accuracy: 0.9821</a:t>
+            </a:r>
+          </a:p>
+          <a:p>
+            <a:r>
+              <a:rPr lang="en-US" dirty="0"/>
+              <a:t>Observation: Decreased accuracy by 0.0038, increased loss by 0.01653</a:t>
+            </a:r>
           </a:p>
         </p:txBody>
       </p:sp>
@@ -4784,41 +4797,25 @@
           <a:p>
             <a:r>
               <a:rPr lang="en-US" sz="1100" dirty="0"/>
-              <a:t>Variation 2 – Dropout: 0.9924</a:t>
+              <a:t>Variation 2 – Dropout: 0.9922</a:t>
             </a:r>
           </a:p>
           <a:p>
             <a:r>
               <a:rPr lang="en-US" sz="1100" dirty="0"/>
-              <a:t>Variation 3 – More Epochs: </a:t>
-            </a:r>
-            <a:r>
-              <a:rPr lang="en-US" sz="1100" dirty="0">
-                <a:highlight>
-                  <a:srgbClr val="FFFF00"/>
-                </a:highlight>
-              </a:rPr>
-              <a:t>(Insert accuracy)</a:t>
+              <a:t>Variation 3 – More Epochs: 0.9914</a:t>
             </a:r>
           </a:p>
           <a:p>
             <a:r>
               <a:rPr lang="en-US" sz="1100" dirty="0"/>
-              <a:t>Variation 4 – SGD Optimizer: </a:t>
-            </a:r>
-            <a:r>
-              <a:rPr lang="en-US" sz="1100" dirty="0">
-                <a:highlight>
-                  <a:srgbClr val="FFFF00"/>
-                </a:highlight>
-              </a:rPr>
-              <a:t>(Insert accuracy)</a:t>
+              <a:t>Variation 4 – SGD Optimizer: 0.9859</a:t>
             </a:r>
           </a:p>
           <a:p>
             <a:r>
               <a:rPr lang="en-US" sz="1100" dirty="0"/>
-              <a:t>Variation 5 – Extra Conv Layer: 0.9871</a:t>
+              <a:t>Variation 5 – Extra Conv Layer: 0.9821</a:t>
             </a:r>
           </a:p>
           <a:p>

</xml_diff>